<commit_message>
modified:   README.md 	modified:   "\343\200\212\345\215\203\345\271\264\345\234\237\345\234\260\347\277\273\344\272\206\350\272\253\343\200\213.pptx" 	modified:   "\347\273\204\345\206\205\346\210\220\345\221\230\350\241\250.xlsx" 	deleted:    "\347\276\216\346\234\257\345\260\217\347\273\20420260911\345\215\203\345\271\264\345\234\237\345\234\260\347\277\273\344\272\206\350\272\253.pptx"
</commit_message>
<xml_diff>
--- a/《千年土地翻了身》.pptx
+++ b/《千年土地翻了身》.pptx
@@ -5,17 +5,19 @@
     <p:sldMasterId id="2147483680" r:id="rId1"/>
   </p:sldMasterIdLst>
   <p:notesMasterIdLst>
-    <p:notesMasterId r:id="rId5"/>
+    <p:notesMasterId r:id="rId7"/>
   </p:notesMasterIdLst>
   <p:sldIdLst>
     <p:sldId id="257" r:id="rId2"/>
     <p:sldId id="256" r:id="rId3"/>
-    <p:sldId id="258" r:id="rId4"/>
+    <p:sldId id="261" r:id="rId4"/>
+    <p:sldId id="260" r:id="rId5"/>
+    <p:sldId id="259" r:id="rId6"/>
   </p:sldIdLst>
   <p:sldSz cx="12192000" cy="6858000"/>
   <p:notesSz cx="6858000" cy="9144000"/>
   <p:custDataLst>
-    <p:tags r:id="rId6"/>
+    <p:tags r:id="rId8"/>
   </p:custDataLst>
   <p:defaultTextStyle>
     <a:defPPr>
@@ -120,6 +122,11 @@
             <a:srgbClr val="A4A3A4"/>
           </p15:clr>
         </p15:guide>
+        <p15:guide id="2" pos="3840">
+          <p15:clr>
+            <a:srgbClr val="A4A3A4"/>
+          </p15:clr>
+        </p15:guide>
       </p15:sldGuideLst>
     </p:ext>
   </p:extLst>
@@ -473,90 +480,6 @@
     </a:lvl9pPr>
   </p:notesStyle>
 </p:notesMaster>
-</file>
-
-<file path=ppt/notesSlides/notesSlide1.xml><?xml version="1.0" encoding="utf-8"?>
-<p:notes xmlns:a="http://schemas.openxmlformats.org/drawingml/2006/main" xmlns:r="http://schemas.openxmlformats.org/officeDocument/2006/relationships" xmlns:p="http://schemas.openxmlformats.org/presentationml/2006/main">
-  <p:cSld>
-    <p:spTree>
-      <p:nvGrpSpPr>
-        <p:cNvPr id="1" name=""/>
-        <p:cNvGrpSpPr/>
-        <p:nvPr/>
-      </p:nvGrpSpPr>
-      <p:grpSpPr>
-        <a:xfrm>
-          <a:off x="0" y="0"/>
-          <a:ext cx="0" cy="0"/>
-          <a:chOff x="0" y="0"/>
-          <a:chExt cx="0" cy="0"/>
-        </a:xfrm>
-      </p:grpSpPr>
-      <p:sp>
-        <p:nvSpPr>
-          <p:cNvPr id="2" name="幻灯片图像占位符 1"/>
-          <p:cNvSpPr>
-            <a:spLocks noGrp="1" noRot="1" noChangeAspect="1"/>
-          </p:cNvSpPr>
-          <p:nvPr>
-            <p:ph type="sldImg"/>
-          </p:nvPr>
-        </p:nvSpPr>
-        <p:spPr/>
-      </p:sp>
-      <p:sp>
-        <p:nvSpPr>
-          <p:cNvPr id="3" name="备注占位符 2"/>
-          <p:cNvSpPr>
-            <a:spLocks noGrp="1"/>
-          </p:cNvSpPr>
-          <p:nvPr>
-            <p:ph type="body" idx="1"/>
-          </p:nvPr>
-        </p:nvSpPr>
-        <p:spPr/>
-        <p:txBody>
-          <a:bodyPr/>
-          <a:lstStyle/>
-          <a:p>
-            <a:endParaRPr lang="zh-CN" altLang="en-US" dirty="0"/>
-          </a:p>
-        </p:txBody>
-      </p:sp>
-      <p:sp>
-        <p:nvSpPr>
-          <p:cNvPr id="4" name="灯片编号占位符 3"/>
-          <p:cNvSpPr>
-            <a:spLocks noGrp="1"/>
-          </p:cNvSpPr>
-          <p:nvPr>
-            <p:ph type="sldNum" sz="quarter" idx="5"/>
-          </p:nvPr>
-        </p:nvSpPr>
-        <p:spPr/>
-        <p:txBody>
-          <a:bodyPr/>
-          <a:lstStyle/>
-          <a:p>
-            <a:fld id="{00663539-D09A-4CC5-B1DC-A96ED30FCB94}" type="slidenum">
-              <a:rPr lang="zh-CN" altLang="en-US" smtClean="0"/>
-              <a:t>3</a:t>
-            </a:fld>
-            <a:endParaRPr lang="zh-CN" altLang="en-US"/>
-          </a:p>
-        </p:txBody>
-      </p:sp>
-    </p:spTree>
-    <p:extLst>
-      <p:ext uri="{BB962C8B-B14F-4D97-AF65-F5344CB8AC3E}">
-        <p14:creationId xmlns:p14="http://schemas.microsoft.com/office/powerpoint/2010/main" val="2433876061"/>
-      </p:ext>
-    </p:extLst>
-  </p:cSld>
-  <p:clrMapOvr>
-    <a:masterClrMapping/>
-  </p:clrMapOvr>
-</p:notes>
 </file>
 
 <file path=ppt/slideLayouts/slideLayout1.xml><?xml version="1.0" encoding="utf-8"?>
@@ -8548,13 +8471,13 @@
   <p:clrMapOvr>
     <a:masterClrMapping/>
   </p:clrMapOvr>
-  <mc:AlternateContent xmlns:mc="http://schemas.openxmlformats.org/markup-compatibility/2006">
-    <mc:Choice xmlns:p14="http://schemas.microsoft.com/office/powerpoint/2010/main" Requires="p14">
+  <mc:AlternateContent xmlns:mc="http://schemas.openxmlformats.org/markup-compatibility/2006" xmlns:p14="http://schemas.microsoft.com/office/powerpoint/2010/main">
+    <mc:Choice Requires="p14">
       <p:transition spd="slow" p14:dur="1600">
         <p:blinds dir="vert"/>
       </p:transition>
     </mc:Choice>
-    <mc:Fallback>
+    <mc:Fallback xmlns="">
       <p:transition spd="slow">
         <p:blinds dir="vert"/>
       </p:transition>
@@ -8633,23 +8556,36 @@
         </p:nvSpPr>
         <p:spPr>
           <a:xfrm>
-            <a:off x="4261198" y="1050435"/>
-            <a:ext cx="4739692" cy="941861"/>
+            <a:off x="1279902" y="1863724"/>
+            <a:ext cx="4213781" cy="590278"/>
           </a:xfrm>
         </p:spPr>
         <p:txBody>
           <a:bodyPr/>
           <a:lstStyle/>
           <a:p>
-            <a:r>
-              <a:rPr lang="zh-CN" altLang="en-US" dirty="0"/>
+            <a:pPr algn="r"/>
+            <a:r>
+              <a:rPr lang="zh-CN" altLang="en-US" dirty="0">
+                <a:latin typeface="楷体" panose="02010609060101010101" pitchFamily="49" charset="-122"/>
+                <a:ea typeface="楷体" panose="02010609060101010101" pitchFamily="49" charset="-122"/>
+              </a:rPr>
               <a:t>内容</a:t>
             </a:r>
             <a:r>
-              <a:rPr lang="en-US" altLang="zh-CN" dirty="0"/>
-              <a:t>1</a:t>
-            </a:r>
-            <a:endParaRPr lang="zh-CN" altLang="en-US" dirty="0"/>
+              <a:rPr lang="en-US" altLang="zh-CN" dirty="0">
+                <a:latin typeface="楷体" panose="02010609060101010101" pitchFamily="49" charset="-122"/>
+                <a:ea typeface="楷体" panose="02010609060101010101" pitchFamily="49" charset="-122"/>
+              </a:rPr>
+              <a:t>1 </a:t>
+            </a:r>
+            <a:r>
+              <a:rPr lang="zh-CN" altLang="en-US" dirty="0">
+                <a:latin typeface="楷体" panose="02010609060101010101" pitchFamily="49" charset="-122"/>
+                <a:ea typeface="楷体" panose="02010609060101010101" pitchFamily="49" charset="-122"/>
+              </a:rPr>
+              <a:t>图片简介</a:t>
+            </a:r>
           </a:p>
         </p:txBody>
       </p:sp>
@@ -8671,8 +8607,8 @@
         </p:nvSpPr>
         <p:spPr>
           <a:xfrm>
-            <a:off x="5493684" y="2628407"/>
-            <a:ext cx="3999001" cy="576262"/>
+            <a:off x="5493683" y="3369225"/>
+            <a:ext cx="4213781" cy="715404"/>
           </a:xfrm>
         </p:spPr>
         <p:txBody>
@@ -8680,14 +8616,26 @@
           <a:lstStyle/>
           <a:p>
             <a:r>
-              <a:rPr lang="zh-CN" altLang="en-US" dirty="0"/>
+              <a:rPr lang="zh-CN" altLang="en-US" dirty="0">
+                <a:latin typeface="楷体" panose="02010609060101010101" pitchFamily="49" charset="-122"/>
+                <a:ea typeface="楷体" panose="02010609060101010101" pitchFamily="49" charset="-122"/>
+              </a:rPr>
               <a:t>内容</a:t>
             </a:r>
             <a:r>
-              <a:rPr lang="en-US" altLang="zh-CN" dirty="0"/>
-              <a:t>2</a:t>
-            </a:r>
-            <a:endParaRPr lang="zh-CN" altLang="en-US" dirty="0"/>
+              <a:rPr lang="en-US" altLang="zh-CN" dirty="0">
+                <a:latin typeface="楷体" panose="02010609060101010101" pitchFamily="49" charset="-122"/>
+                <a:ea typeface="楷体" panose="02010609060101010101" pitchFamily="49" charset="-122"/>
+              </a:rPr>
+              <a:t>2 </a:t>
+            </a:r>
+            <a:r>
+              <a:rPr lang="zh-CN" altLang="en-US" dirty="0">
+                <a:latin typeface="楷体" panose="02010609060101010101" pitchFamily="49" charset="-122"/>
+                <a:ea typeface="楷体" panose="02010609060101010101" pitchFamily="49" charset="-122"/>
+              </a:rPr>
+              <a:t>内容演绎</a:t>
+            </a:r>
           </a:p>
         </p:txBody>
       </p:sp>
@@ -8709,8 +8657,8 @@
         </p:nvSpPr>
         <p:spPr>
           <a:xfrm>
-            <a:off x="4239778" y="4047709"/>
-            <a:ext cx="4178358" cy="924657"/>
+            <a:off x="1279900" y="4999853"/>
+            <a:ext cx="4213783" cy="715404"/>
           </a:xfrm>
         </p:spPr>
         <p:txBody>
@@ -8719,449 +8667,29 @@
           </a:bodyPr>
           <a:lstStyle/>
           <a:p>
-            <a:pPr marL="0" indent="0">
+            <a:pPr marL="0" indent="0" algn="r">
               <a:buNone/>
             </a:pPr>
             <a:r>
-              <a:rPr lang="zh-CN" altLang="en-US" sz="2400" dirty="0"/>
+              <a:rPr lang="zh-CN" altLang="en-US" sz="2400" dirty="0">
+                <a:latin typeface="楷体" panose="02010609060101010101" pitchFamily="49" charset="-122"/>
+                <a:ea typeface="楷体" panose="02010609060101010101" pitchFamily="49" charset="-122"/>
+              </a:rPr>
               <a:t>内容</a:t>
             </a:r>
             <a:r>
-              <a:rPr lang="en-US" altLang="zh-CN" sz="2400" dirty="0"/>
-              <a:t>3</a:t>
-            </a:r>
-            <a:endParaRPr lang="zh-CN" altLang="en-US" sz="2400" dirty="0"/>
-          </a:p>
-        </p:txBody>
-      </p:sp>
-      <p:pic>
-        <p:nvPicPr>
-          <p:cNvPr id="12" name="图片 11">
-            <a:extLst>
-              <a:ext uri="{FF2B5EF4-FFF2-40B4-BE49-F238E27FC236}">
-                <a16:creationId xmlns:a16="http://schemas.microsoft.com/office/drawing/2014/main" id="{88425770-F2EC-6A1B-D4E5-897FC0C5CB79}"/>
-              </a:ext>
-            </a:extLst>
-          </p:cNvPr>
-          <p:cNvPicPr>
-            <a:picLocks noChangeAspect="1"/>
-          </p:cNvPicPr>
-          <p:nvPr/>
-        </p:nvPicPr>
-        <p:blipFill>
-          <a:blip r:embed="rId2">
-            <a:extLst>
-              <a:ext uri="{28A0092B-C50C-407E-A947-70E740481C1C}">
-                <a14:useLocalDpi xmlns:a14="http://schemas.microsoft.com/office/drawing/2010/main" val="0"/>
-              </a:ext>
-            </a:extLst>
-          </a:blip>
-          <a:stretch>
-            <a:fillRect/>
-          </a:stretch>
-        </p:blipFill>
-        <p:spPr>
-          <a:xfrm>
-            <a:off x="8794044" y="1909692"/>
-            <a:ext cx="1787017" cy="2074320"/>
-          </a:xfrm>
-          <a:prstGeom prst="rect">
-            <a:avLst/>
-          </a:prstGeom>
-        </p:spPr>
-      </p:pic>
-      <p:sp>
-        <p:nvSpPr>
-          <p:cNvPr id="14" name="内容占位符 13">
-            <a:extLst>
-              <a:ext uri="{FF2B5EF4-FFF2-40B4-BE49-F238E27FC236}">
-                <a16:creationId xmlns:a16="http://schemas.microsoft.com/office/drawing/2014/main" id="{D53A3EB3-0A54-93E0-282F-81A134ED7DC2}"/>
-              </a:ext>
-            </a:extLst>
-          </p:cNvPr>
-          <p:cNvSpPr>
-            <a:spLocks noGrp="1"/>
-          </p:cNvSpPr>
-          <p:nvPr>
-            <p:ph sz="half" idx="2"/>
-          </p:nvPr>
-        </p:nvSpPr>
-        <p:spPr>
-          <a:xfrm>
-            <a:off x="5493684" y="5537585"/>
-            <a:ext cx="3171618" cy="576262"/>
-          </a:xfrm>
-        </p:spPr>
-        <p:txBody>
-          <a:bodyPr>
-            <a:normAutofit/>
-          </a:bodyPr>
-          <a:lstStyle/>
-          <a:p>
-            <a:pPr marL="0" indent="0">
-              <a:buNone/>
-            </a:pPr>
-            <a:r>
-              <a:rPr lang="zh-CN" altLang="en-US" sz="2400" dirty="0"/>
-              <a:t>内容</a:t>
-            </a:r>
-            <a:r>
-              <a:rPr lang="en-US" altLang="zh-CN" sz="2400" dirty="0"/>
-              <a:t>4</a:t>
-            </a:r>
-            <a:endParaRPr lang="zh-CN" altLang="en-US" sz="2400" dirty="0"/>
-          </a:p>
-        </p:txBody>
-      </p:sp>
-      <p:pic>
-        <p:nvPicPr>
-          <p:cNvPr id="16" name="图片 15">
-            <a:extLst>
-              <a:ext uri="{FF2B5EF4-FFF2-40B4-BE49-F238E27FC236}">
-                <a16:creationId xmlns:a16="http://schemas.microsoft.com/office/drawing/2014/main" id="{D7546934-C3C8-FB43-60FD-4A96F6F88A58}"/>
-              </a:ext>
-            </a:extLst>
-          </p:cNvPr>
-          <p:cNvPicPr>
-            <a:picLocks noChangeAspect="1"/>
-          </p:cNvPicPr>
-          <p:nvPr/>
-        </p:nvPicPr>
-        <p:blipFill>
-          <a:blip r:embed="rId3">
-            <a:extLst>
-              <a:ext uri="{28A0092B-C50C-407E-A947-70E740481C1C}">
-                <a14:useLocalDpi xmlns:a14="http://schemas.microsoft.com/office/drawing/2010/main" val="0"/>
-              </a:ext>
-            </a:extLst>
-          </a:blip>
-          <a:stretch>
-            <a:fillRect/>
-          </a:stretch>
-        </p:blipFill>
-        <p:spPr>
-          <a:xfrm>
-            <a:off x="1972940" y="626603"/>
-            <a:ext cx="1600215" cy="1634927"/>
-          </a:xfrm>
-          <a:prstGeom prst="rect">
-            <a:avLst/>
-          </a:prstGeom>
-        </p:spPr>
-      </p:pic>
-      <p:pic>
-        <p:nvPicPr>
-          <p:cNvPr id="18" name="图片 17">
-            <a:extLst>
-              <a:ext uri="{FF2B5EF4-FFF2-40B4-BE49-F238E27FC236}">
-                <a16:creationId xmlns:a16="http://schemas.microsoft.com/office/drawing/2014/main" id="{E998AF42-05F7-0930-F872-957BD5509514}"/>
-              </a:ext>
-            </a:extLst>
-          </p:cNvPr>
-          <p:cNvPicPr>
-            <a:picLocks noChangeAspect="1"/>
-          </p:cNvPicPr>
-          <p:nvPr/>
-        </p:nvPicPr>
-        <p:blipFill>
-          <a:blip r:embed="rId4">
-            <a:extLst>
-              <a:ext uri="{28A0092B-C50C-407E-A947-70E740481C1C}">
-                <a14:useLocalDpi xmlns:a14="http://schemas.microsoft.com/office/drawing/2010/main" val="0"/>
-              </a:ext>
-            </a:extLst>
-          </a:blip>
-          <a:stretch>
-            <a:fillRect/>
-          </a:stretch>
-        </p:blipFill>
-        <p:spPr>
-          <a:xfrm>
-            <a:off x="1616012" y="2213522"/>
-            <a:ext cx="1891112" cy="1770490"/>
-          </a:xfrm>
-          <a:prstGeom prst="rect">
-            <a:avLst/>
-          </a:prstGeom>
-        </p:spPr>
-      </p:pic>
-      <p:pic>
-        <p:nvPicPr>
-          <p:cNvPr id="20" name="图片 19">
-            <a:extLst>
-              <a:ext uri="{FF2B5EF4-FFF2-40B4-BE49-F238E27FC236}">
-                <a16:creationId xmlns:a16="http://schemas.microsoft.com/office/drawing/2014/main" id="{F1F7A8B6-ADB7-D94B-EE4F-B38ED82C31D1}"/>
-              </a:ext>
-            </a:extLst>
-          </p:cNvPr>
-          <p:cNvPicPr>
-            <a:picLocks noChangeAspect="1"/>
-          </p:cNvPicPr>
-          <p:nvPr/>
-        </p:nvPicPr>
-        <p:blipFill>
-          <a:blip r:embed="rId5">
-            <a:extLst>
-              <a:ext uri="{28A0092B-C50C-407E-A947-70E740481C1C}">
-                <a14:useLocalDpi xmlns:a14="http://schemas.microsoft.com/office/drawing/2010/main" val="0"/>
-              </a:ext>
-            </a:extLst>
-          </a:blip>
-          <a:stretch>
-            <a:fillRect/>
-          </a:stretch>
-        </p:blipFill>
-        <p:spPr>
-          <a:xfrm>
-            <a:off x="1687107" y="4023474"/>
-            <a:ext cx="2146741" cy="1720942"/>
-          </a:xfrm>
-          <a:prstGeom prst="rect">
-            <a:avLst/>
-          </a:prstGeom>
-        </p:spPr>
-      </p:pic>
-      <p:pic>
-        <p:nvPicPr>
-          <p:cNvPr id="22" name="图片 21">
-            <a:extLst>
-              <a:ext uri="{FF2B5EF4-FFF2-40B4-BE49-F238E27FC236}">
-                <a16:creationId xmlns:a16="http://schemas.microsoft.com/office/drawing/2014/main" id="{4B49C231-ECFF-CDC8-AEBA-1AE8F84C9724}"/>
-              </a:ext>
-            </a:extLst>
-          </p:cNvPr>
-          <p:cNvPicPr>
-            <a:picLocks noChangeAspect="1"/>
-          </p:cNvPicPr>
-          <p:nvPr/>
-        </p:nvPicPr>
-        <p:blipFill>
-          <a:blip r:embed="rId6">
-            <a:extLst>
-              <a:ext uri="{28A0092B-C50C-407E-A947-70E740481C1C}">
-                <a14:useLocalDpi xmlns:a14="http://schemas.microsoft.com/office/drawing/2010/main" val="0"/>
-              </a:ext>
-            </a:extLst>
-          </a:blip>
-          <a:stretch>
-            <a:fillRect/>
-          </a:stretch>
-        </p:blipFill>
-        <p:spPr>
-          <a:xfrm>
-            <a:off x="8159476" y="4949057"/>
-            <a:ext cx="3056155" cy="1717015"/>
-          </a:xfrm>
-          <a:prstGeom prst="rect">
-            <a:avLst/>
-          </a:prstGeom>
-        </p:spPr>
-      </p:pic>
-      <p:sp>
-        <p:nvSpPr>
-          <p:cNvPr id="24" name="对话气泡: 椭圆形 23">
-            <a:extLst>
-              <a:ext uri="{FF2B5EF4-FFF2-40B4-BE49-F238E27FC236}">
-                <a16:creationId xmlns:a16="http://schemas.microsoft.com/office/drawing/2014/main" id="{BE45A7FD-1088-2A00-1551-619FA668D6C9}"/>
-              </a:ext>
-            </a:extLst>
-          </p:cNvPr>
-          <p:cNvSpPr/>
-          <p:nvPr/>
-        </p:nvSpPr>
-        <p:spPr>
-          <a:xfrm flipH="1">
-            <a:off x="59299" y="162021"/>
-            <a:ext cx="1913641" cy="1282045"/>
-          </a:xfrm>
-          <a:prstGeom prst="wedgeEllipseCallout">
-            <a:avLst>
-              <a:gd name="adj1" fmla="val -43493"/>
-              <a:gd name="adj2" fmla="val 64706"/>
-            </a:avLst>
-          </a:prstGeom>
-        </p:spPr>
-        <p:style>
-          <a:lnRef idx="2">
-            <a:schemeClr val="accent1">
-              <a:shade val="15000"/>
-            </a:schemeClr>
-          </a:lnRef>
-          <a:fillRef idx="1">
-            <a:schemeClr val="accent1"/>
-          </a:fillRef>
-          <a:effectRef idx="0">
-            <a:schemeClr val="accent1"/>
-          </a:effectRef>
-          <a:fontRef idx="minor">
-            <a:schemeClr val="lt1"/>
-          </a:fontRef>
-        </p:style>
-        <p:txBody>
-          <a:bodyPr rtlCol="0" anchor="ctr"/>
-          <a:lstStyle/>
-          <a:p>
-            <a:pPr algn="ctr"/>
-            <a:r>
-              <a:rPr lang="zh-CN" altLang="en-US" dirty="0"/>
-              <a:t>闲的没事干出去炸个鱼与玩玩</a:t>
-            </a:r>
-          </a:p>
-        </p:txBody>
-      </p:sp>
-      <p:sp>
-        <p:nvSpPr>
-          <p:cNvPr id="25" name="对话气泡: 圆角矩形 24">
-            <a:extLst>
-              <a:ext uri="{FF2B5EF4-FFF2-40B4-BE49-F238E27FC236}">
-                <a16:creationId xmlns:a16="http://schemas.microsoft.com/office/drawing/2014/main" id="{9ADE14AA-D4AF-4CE9-D7F3-7E74838F2613}"/>
-              </a:ext>
-            </a:extLst>
-          </p:cNvPr>
-          <p:cNvSpPr/>
-          <p:nvPr/>
-        </p:nvSpPr>
-        <p:spPr>
-          <a:xfrm flipH="1">
-            <a:off x="0" y="1558169"/>
-            <a:ext cx="1376314" cy="1282045"/>
-          </a:xfrm>
-          <a:prstGeom prst="wedgeRoundRectCallout">
-            <a:avLst>
-              <a:gd name="adj1" fmla="val -57819"/>
-              <a:gd name="adj2" fmla="val 83824"/>
-              <a:gd name="adj3" fmla="val 16667"/>
-            </a:avLst>
-          </a:prstGeom>
-        </p:spPr>
-        <p:style>
-          <a:lnRef idx="2">
-            <a:schemeClr val="accent1">
-              <a:shade val="15000"/>
-            </a:schemeClr>
-          </a:lnRef>
-          <a:fillRef idx="1">
-            <a:schemeClr val="accent1"/>
-          </a:fillRef>
-          <a:effectRef idx="0">
-            <a:schemeClr val="accent1"/>
-          </a:effectRef>
-          <a:fontRef idx="minor">
-            <a:schemeClr val="lt1"/>
-          </a:fontRef>
-        </p:style>
-        <p:txBody>
-          <a:bodyPr rtlCol="0" anchor="ctr"/>
-          <a:lstStyle/>
-          <a:p>
-            <a:pPr algn="ctr"/>
-            <a:r>
-              <a:rPr lang="zh-CN" altLang="en-US" dirty="0"/>
-              <a:t>小妹妹，我们来下棋吧</a:t>
-            </a:r>
-          </a:p>
-        </p:txBody>
-      </p:sp>
-      <p:sp>
-        <p:nvSpPr>
-          <p:cNvPr id="26" name="对话气泡: 矩形 25">
-            <a:extLst>
-              <a:ext uri="{FF2B5EF4-FFF2-40B4-BE49-F238E27FC236}">
-                <a16:creationId xmlns:a16="http://schemas.microsoft.com/office/drawing/2014/main" id="{5C37F8BC-243D-0B17-1509-5920523601E5}"/>
-              </a:ext>
-            </a:extLst>
-          </p:cNvPr>
-          <p:cNvSpPr/>
-          <p:nvPr/>
-        </p:nvSpPr>
-        <p:spPr>
-          <a:xfrm>
-            <a:off x="10916643" y="662847"/>
-            <a:ext cx="1216058" cy="996001"/>
-          </a:xfrm>
-          <a:prstGeom prst="wedgeRectCallout">
-            <a:avLst>
-              <a:gd name="adj1" fmla="val -86724"/>
-              <a:gd name="adj2" fmla="val 89001"/>
-            </a:avLst>
-          </a:prstGeom>
-        </p:spPr>
-        <p:style>
-          <a:lnRef idx="2">
-            <a:schemeClr val="accent1">
-              <a:shade val="15000"/>
-            </a:schemeClr>
-          </a:lnRef>
-          <a:fillRef idx="1">
-            <a:schemeClr val="accent1"/>
-          </a:fillRef>
-          <a:effectRef idx="0">
-            <a:schemeClr val="accent1"/>
-          </a:effectRef>
-          <a:fontRef idx="minor">
-            <a:schemeClr val="lt1"/>
-          </a:fontRef>
-        </p:style>
-        <p:txBody>
-          <a:bodyPr rtlCol="0" anchor="ctr"/>
-          <a:lstStyle/>
-          <a:p>
-            <a:pPr algn="ctr"/>
-            <a:r>
-              <a:rPr lang="zh-CN" altLang="en-US" dirty="0"/>
-              <a:t>看我直接将你顽童戏老叟</a:t>
-            </a:r>
-          </a:p>
-        </p:txBody>
-      </p:sp>
-      <p:sp>
-        <p:nvSpPr>
-          <p:cNvPr id="27" name="对话气泡: 椭圆形 26">
-            <a:extLst>
-              <a:ext uri="{FF2B5EF4-FFF2-40B4-BE49-F238E27FC236}">
-                <a16:creationId xmlns:a16="http://schemas.microsoft.com/office/drawing/2014/main" id="{1B31C38E-688E-31E1-185C-FE110A0EB5CE}"/>
-              </a:ext>
-            </a:extLst>
-          </p:cNvPr>
-          <p:cNvSpPr/>
-          <p:nvPr/>
-        </p:nvSpPr>
-        <p:spPr>
-          <a:xfrm>
-            <a:off x="-141403" y="3429000"/>
-            <a:ext cx="1891111" cy="1543366"/>
-          </a:xfrm>
-          <a:prstGeom prst="wedgeEllipseCallout">
-            <a:avLst>
-              <a:gd name="adj1" fmla="val 46073"/>
-              <a:gd name="adj2" fmla="val 65747"/>
-            </a:avLst>
-          </a:prstGeom>
-        </p:spPr>
-        <p:style>
-          <a:lnRef idx="2">
-            <a:schemeClr val="accent1">
-              <a:shade val="15000"/>
-            </a:schemeClr>
-          </a:lnRef>
-          <a:fillRef idx="1">
-            <a:schemeClr val="accent1"/>
-          </a:fillRef>
-          <a:effectRef idx="0">
-            <a:schemeClr val="accent1"/>
-          </a:effectRef>
-          <a:fontRef idx="minor">
-            <a:schemeClr val="lt1"/>
-          </a:fontRef>
-        </p:style>
-        <p:txBody>
-          <a:bodyPr rtlCol="0" anchor="ctr"/>
-          <a:lstStyle/>
-          <a:p>
-            <a:pPr algn="ctr"/>
-            <a:r>
-              <a:rPr lang="zh-CN" altLang="en-US" dirty="0"/>
-              <a:t>其实我后面还有人，赢你我都不需要出手</a:t>
+              <a:rPr lang="en-US" altLang="zh-CN" sz="2400" dirty="0">
+                <a:latin typeface="楷体" panose="02010609060101010101" pitchFamily="49" charset="-122"/>
+                <a:ea typeface="楷体" panose="02010609060101010101" pitchFamily="49" charset="-122"/>
+              </a:rPr>
+              <a:t>3 </a:t>
+            </a:r>
+            <a:r>
+              <a:rPr lang="zh-CN" altLang="en-US" sz="2400" dirty="0">
+                <a:latin typeface="楷体" panose="02010609060101010101" pitchFamily="49" charset="-122"/>
+                <a:ea typeface="楷体" panose="02010609060101010101" pitchFamily="49" charset="-122"/>
+              </a:rPr>
+              <a:t>分工与鸣谢</a:t>
             </a:r>
           </a:p>
         </p:txBody>
@@ -9176,13 +8704,13 @@
   <p:clrMapOvr>
     <a:masterClrMapping/>
   </p:clrMapOvr>
-  <mc:AlternateContent xmlns:mc="http://schemas.openxmlformats.org/markup-compatibility/2006">
-    <mc:Choice xmlns:p14="http://schemas.microsoft.com/office/powerpoint/2010/main" Requires="p14">
+  <mc:AlternateContent xmlns:mc="http://schemas.openxmlformats.org/markup-compatibility/2006" xmlns:p14="http://schemas.microsoft.com/office/powerpoint/2010/main">
+    <mc:Choice Requires="p14">
       <p:transition spd="slow" p14:dur="2000">
         <p14:prism isContent="1"/>
       </p:transition>
     </mc:Choice>
-    <mc:Fallback>
+    <mc:Fallback xmlns="">
       <p:transition spd="slow">
         <p:fade/>
       </p:transition>
@@ -9200,6 +8728,9 @@
                     <p:cTn id="3" fill="hold">
                       <p:stCondLst>
                         <p:cond delay="indefinite"/>
+                        <p:cond evt="onBegin" delay="0">
+                          <p:tn val="2"/>
+                        </p:cond>
                       </p:stCondLst>
                       <p:childTnLst>
                         <p:par>
@@ -9209,7 +8740,7 @@
                             </p:stCondLst>
                             <p:childTnLst>
                               <p:par>
-                                <p:cTn id="5" presetID="45" presetClass="entr" presetSubtype="0" fill="hold" nodeType="clickEffect">
+                                <p:cTn id="5" presetID="14" presetClass="entr" presetSubtype="10" fill="hold" grpId="0" nodeType="withEffect">
                                   <p:stCondLst>
                                     <p:cond delay="0"/>
                                   </p:stCondLst>
@@ -9217,156 +8748,6 @@
                                     <p:set>
                                       <p:cBhvr>
                                         <p:cTn id="6" dur="1" fill="hold">
-                                          <p:stCondLst>
-                                            <p:cond delay="0"/>
-                                          </p:stCondLst>
-                                        </p:cTn>
-                                        <p:tgtEl>
-                                          <p:spTgt spid="16"/>
-                                        </p:tgtEl>
-                                        <p:attrNameLst>
-                                          <p:attrName>style.visibility</p:attrName>
-                                        </p:attrNameLst>
-                                      </p:cBhvr>
-                                      <p:to>
-                                        <p:strVal val="visible"/>
-                                      </p:to>
-                                    </p:set>
-                                    <p:animEffect transition="in" filter="fade">
-                                      <p:cBhvr>
-                                        <p:cTn id="7" dur="1250"/>
-                                        <p:tgtEl>
-                                          <p:spTgt spid="16"/>
-                                        </p:tgtEl>
-                                      </p:cBhvr>
-                                    </p:animEffect>
-                                    <p:anim calcmode="lin" valueType="num">
-                                      <p:cBhvr>
-                                        <p:cTn id="8" dur="1250" fill="hold"/>
-                                        <p:tgtEl>
-                                          <p:spTgt spid="16"/>
-                                        </p:tgtEl>
-                                        <p:attrNameLst>
-                                          <p:attrName>ppt_w</p:attrName>
-                                        </p:attrNameLst>
-                                      </p:cBhvr>
-                                      <p:tavLst>
-                                        <p:tav tm="0" fmla="#ppt_w*sin(2.5*pi*$)">
-                                          <p:val>
-                                            <p:fltVal val="0"/>
-                                          </p:val>
-                                        </p:tav>
-                                        <p:tav tm="100000">
-                                          <p:val>
-                                            <p:fltVal val="1"/>
-                                          </p:val>
-                                        </p:tav>
-                                      </p:tavLst>
-                                    </p:anim>
-                                    <p:anim calcmode="lin" valueType="num">
-                                      <p:cBhvr>
-                                        <p:cTn id="9" dur="1250" fill="hold"/>
-                                        <p:tgtEl>
-                                          <p:spTgt spid="16"/>
-                                        </p:tgtEl>
-                                        <p:attrNameLst>
-                                          <p:attrName>ppt_h</p:attrName>
-                                        </p:attrNameLst>
-                                      </p:cBhvr>
-                                      <p:tavLst>
-                                        <p:tav tm="0">
-                                          <p:val>
-                                            <p:strVal val="#ppt_h"/>
-                                          </p:val>
-                                        </p:tav>
-                                        <p:tav tm="100000">
-                                          <p:val>
-                                            <p:strVal val="#ppt_h"/>
-                                          </p:val>
-                                        </p:tav>
-                                      </p:tavLst>
-                                    </p:anim>
-                                  </p:childTnLst>
-                                </p:cTn>
-                              </p:par>
-                              <p:par>
-                                <p:cTn id="10" presetID="1" presetClass="entr" presetSubtype="0" fill="hold" nodeType="withEffect">
-                                  <p:stCondLst>
-                                    <p:cond delay="0"/>
-                                  </p:stCondLst>
-                                  <p:childTnLst>
-                                    <p:set>
-                                      <p:cBhvr>
-                                        <p:cTn id="11" dur="1" fill="hold">
-                                          <p:stCondLst>
-                                            <p:cond delay="0"/>
-                                          </p:stCondLst>
-                                        </p:cTn>
-                                        <p:tgtEl>
-                                          <p:spTgt spid="24">
-                                            <p:txEl>
-                                              <p:pRg st="0" end="0"/>
-                                            </p:txEl>
-                                          </p:spTgt>
-                                        </p:tgtEl>
-                                        <p:attrNameLst>
-                                          <p:attrName>style.visibility</p:attrName>
-                                        </p:attrNameLst>
-                                      </p:cBhvr>
-                                      <p:to>
-                                        <p:strVal val="visible"/>
-                                      </p:to>
-                                    </p:set>
-                                  </p:childTnLst>
-                                </p:cTn>
-                              </p:par>
-                            </p:childTnLst>
-                          </p:cTn>
-                        </p:par>
-                      </p:childTnLst>
-                    </p:cTn>
-                  </p:par>
-                  <p:par>
-                    <p:cTn id="12" fill="hold">
-                      <p:stCondLst>
-                        <p:cond delay="indefinite"/>
-                      </p:stCondLst>
-                      <p:childTnLst>
-                        <p:par>
-                          <p:cTn id="13" fill="hold">
-                            <p:stCondLst>
-                              <p:cond delay="0"/>
-                            </p:stCondLst>
-                            <p:childTnLst>
-                              <p:par>
-                                <p:cTn id="14" presetID="8" presetClass="emph" presetSubtype="0" fill="hold" nodeType="clickEffect">
-                                  <p:stCondLst>
-                                    <p:cond delay="0"/>
-                                  </p:stCondLst>
-                                  <p:childTnLst>
-                                    <p:animRot by="21600000">
-                                      <p:cBhvr>
-                                        <p:cTn id="15" dur="1000" fill="hold"/>
-                                        <p:tgtEl>
-                                          <p:spTgt spid="16"/>
-                                        </p:tgtEl>
-                                        <p:attrNameLst>
-                                          <p:attrName>r</p:attrName>
-                                        </p:attrNameLst>
-                                      </p:cBhvr>
-                                    </p:animRot>
-                                  </p:childTnLst>
-                                </p:cTn>
-                              </p:par>
-                              <p:par>
-                                <p:cTn id="16" presetID="14" presetClass="entr" presetSubtype="10" fill="hold" grpId="0" nodeType="withEffect">
-                                  <p:stCondLst>
-                                    <p:cond delay="0"/>
-                                  </p:stCondLst>
-                                  <p:childTnLst>
-                                    <p:set>
-                                      <p:cBhvr>
-                                        <p:cTn id="17" dur="1" fill="hold">
                                           <p:stCondLst>
                                             <p:cond delay="0"/>
                                           </p:stCondLst>
@@ -9388,7 +8769,7 @@
                                     </p:set>
                                     <p:animEffect transition="in" filter="randombar(horizontal)">
                                       <p:cBhvr>
-                                        <p:cTn id="18" dur="500"/>
+                                        <p:cTn id="7" dur="500"/>
                                         <p:tgtEl>
                                           <p:spTgt spid="5">
                                             <p:txEl>
@@ -9401,168 +8782,15 @@
                                   </p:childTnLst>
                                 </p:cTn>
                               </p:par>
-                            </p:childTnLst>
-                          </p:cTn>
-                        </p:par>
-                      </p:childTnLst>
-                    </p:cTn>
-                  </p:par>
-                  <p:par>
-                    <p:cTn id="19" fill="hold">
-                      <p:stCondLst>
-                        <p:cond delay="indefinite"/>
-                      </p:stCondLst>
-                      <p:childTnLst>
-                        <p:par>
-                          <p:cTn id="20" fill="hold">
-                            <p:stCondLst>
-                              <p:cond delay="0"/>
-                            </p:stCondLst>
-                            <p:childTnLst>
                               <p:par>
-                                <p:cTn id="21" presetID="31" presetClass="entr" presetSubtype="0" fill="hold" nodeType="clickEffect">
+                                <p:cTn id="8" presetID="1" presetClass="entr" presetSubtype="0" fill="hold" nodeType="withEffect">
                                   <p:stCondLst>
                                     <p:cond delay="0"/>
                                   </p:stCondLst>
                                   <p:childTnLst>
                                     <p:set>
                                       <p:cBhvr>
-                                        <p:cTn id="22" dur="1" fill="hold">
-                                          <p:stCondLst>
-                                            <p:cond delay="0"/>
-                                          </p:stCondLst>
-                                        </p:cTn>
-                                        <p:tgtEl>
-                                          <p:spTgt spid="18"/>
-                                        </p:tgtEl>
-                                        <p:attrNameLst>
-                                          <p:attrName>style.visibility</p:attrName>
-                                        </p:attrNameLst>
-                                      </p:cBhvr>
-                                      <p:to>
-                                        <p:strVal val="visible"/>
-                                      </p:to>
-                                    </p:set>
-                                    <p:anim calcmode="lin" valueType="num">
-                                      <p:cBhvr>
-                                        <p:cTn id="23" dur="1000" fill="hold"/>
-                                        <p:tgtEl>
-                                          <p:spTgt spid="18"/>
-                                        </p:tgtEl>
-                                        <p:attrNameLst>
-                                          <p:attrName>ppt_w</p:attrName>
-                                        </p:attrNameLst>
-                                      </p:cBhvr>
-                                      <p:tavLst>
-                                        <p:tav tm="0">
-                                          <p:val>
-                                            <p:fltVal val="0"/>
-                                          </p:val>
-                                        </p:tav>
-                                        <p:tav tm="100000">
-                                          <p:val>
-                                            <p:strVal val="#ppt_w"/>
-                                          </p:val>
-                                        </p:tav>
-                                      </p:tavLst>
-                                    </p:anim>
-                                    <p:anim calcmode="lin" valueType="num">
-                                      <p:cBhvr>
-                                        <p:cTn id="24" dur="1000" fill="hold"/>
-                                        <p:tgtEl>
-                                          <p:spTgt spid="18"/>
-                                        </p:tgtEl>
-                                        <p:attrNameLst>
-                                          <p:attrName>ppt_h</p:attrName>
-                                        </p:attrNameLst>
-                                      </p:cBhvr>
-                                      <p:tavLst>
-                                        <p:tav tm="0">
-                                          <p:val>
-                                            <p:fltVal val="0"/>
-                                          </p:val>
-                                        </p:tav>
-                                        <p:tav tm="100000">
-                                          <p:val>
-                                            <p:strVal val="#ppt_h"/>
-                                          </p:val>
-                                        </p:tav>
-                                      </p:tavLst>
-                                    </p:anim>
-                                    <p:anim calcmode="lin" valueType="num">
-                                      <p:cBhvr>
-                                        <p:cTn id="25" dur="1000" fill="hold"/>
-                                        <p:tgtEl>
-                                          <p:spTgt spid="18"/>
-                                        </p:tgtEl>
-                                        <p:attrNameLst>
-                                          <p:attrName>style.rotation</p:attrName>
-                                        </p:attrNameLst>
-                                      </p:cBhvr>
-                                      <p:tavLst>
-                                        <p:tav tm="0">
-                                          <p:val>
-                                            <p:fltVal val="90"/>
-                                          </p:val>
-                                        </p:tav>
-                                        <p:tav tm="100000">
-                                          <p:val>
-                                            <p:fltVal val="0"/>
-                                          </p:val>
-                                        </p:tav>
-                                      </p:tavLst>
-                                    </p:anim>
-                                    <p:animEffect transition="in" filter="fade">
-                                      <p:cBhvr>
-                                        <p:cTn id="26" dur="1000"/>
-                                        <p:tgtEl>
-                                          <p:spTgt spid="18"/>
-                                        </p:tgtEl>
-                                      </p:cBhvr>
-                                    </p:animEffect>
-                                  </p:childTnLst>
-                                </p:cTn>
-                              </p:par>
-                              <p:par>
-                                <p:cTn id="27" presetID="1" presetClass="entr" presetSubtype="0" fill="hold" nodeType="withEffect">
-                                  <p:stCondLst>
-                                    <p:cond delay="0"/>
-                                  </p:stCondLst>
-                                  <p:childTnLst>
-                                    <p:set>
-                                      <p:cBhvr>
-                                        <p:cTn id="28" dur="1" fill="hold">
-                                          <p:stCondLst>
-                                            <p:cond delay="0"/>
-                                          </p:stCondLst>
-                                        </p:cTn>
-                                        <p:tgtEl>
-                                          <p:spTgt spid="25">
-                                            <p:txEl>
-                                              <p:pRg st="0" end="0"/>
-                                            </p:txEl>
-                                          </p:spTgt>
-                                        </p:tgtEl>
-                                        <p:attrNameLst>
-                                          <p:attrName>style.visibility</p:attrName>
-                                        </p:attrNameLst>
-                                      </p:cBhvr>
-                                      <p:to>
-                                        <p:strVal val="visible"/>
-                                      </p:to>
-                                    </p:set>
-                                  </p:childTnLst>
-                                </p:cTn>
-                              </p:par>
-                              <p:par>
-                                <p:cTn id="29" presetID="1" presetClass="entr" presetSubtype="0" fill="hold" nodeType="withEffect">
-                                  <p:stCondLst>
-                                    <p:cond delay="0"/>
-                                  </p:stCondLst>
-                                  <p:childTnLst>
-                                    <p:set>
-                                      <p:cBhvr>
-                                        <p:cTn id="30" dur="1" fill="hold">
+                                        <p:cTn id="9" dur="1" fill="hold">
                                           <p:stCondLst>
                                             <p:cond delay="0"/>
                                           </p:stCondLst>
@@ -9585,562 +8813,21 @@
                                   </p:childTnLst>
                                 </p:cTn>
                               </p:par>
-                            </p:childTnLst>
-                          </p:cTn>
-                        </p:par>
-                      </p:childTnLst>
-                    </p:cTn>
-                  </p:par>
-                  <p:par>
-                    <p:cTn id="31" fill="hold">
-                      <p:stCondLst>
-                        <p:cond delay="indefinite"/>
-                      </p:stCondLst>
-                      <p:childTnLst>
-                        <p:par>
-                          <p:cTn id="32" fill="hold">
-                            <p:stCondLst>
-                              <p:cond delay="0"/>
-                            </p:stCondLst>
-                            <p:childTnLst>
                               <p:par>
-                                <p:cTn id="33" presetID="26" presetClass="entr" presetSubtype="0" fill="hold" nodeType="clickEffect">
+                                <p:cTn id="10" presetID="1" presetClass="entr" presetSubtype="0" fill="hold" nodeType="withEffect">
                                   <p:stCondLst>
                                     <p:cond delay="0"/>
                                   </p:stCondLst>
                                   <p:childTnLst>
                                     <p:set>
                                       <p:cBhvr>
-                                        <p:cTn id="34" dur="1" fill="hold">
-                                          <p:stCondLst>
-                                            <p:cond delay="0"/>
-                                          </p:stCondLst>
-                                        </p:cTn>
-                                        <p:tgtEl>
-                                          <p:spTgt spid="12"/>
-                                        </p:tgtEl>
-                                        <p:attrNameLst>
-                                          <p:attrName>style.visibility</p:attrName>
-                                        </p:attrNameLst>
-                                      </p:cBhvr>
-                                      <p:to>
-                                        <p:strVal val="visible"/>
-                                      </p:to>
-                                    </p:set>
-                                    <p:animEffect transition="in" filter="wipe(down)">
-                                      <p:cBhvr>
-                                        <p:cTn id="35" dur="580">
-                                          <p:stCondLst>
-                                            <p:cond delay="0"/>
-                                          </p:stCondLst>
-                                        </p:cTn>
-                                        <p:tgtEl>
-                                          <p:spTgt spid="12"/>
-                                        </p:tgtEl>
-                                      </p:cBhvr>
-                                    </p:animEffect>
-                                    <p:anim calcmode="lin" valueType="num">
-                                      <p:cBhvr>
-                                        <p:cTn id="36" dur="1822" tmFilter="0,0; 0.14,0.36; 0.43,0.73; 0.71,0.91; 1.0,1.0">
-                                          <p:stCondLst>
-                                            <p:cond delay="0"/>
-                                          </p:stCondLst>
-                                        </p:cTn>
-                                        <p:tgtEl>
-                                          <p:spTgt spid="12"/>
-                                        </p:tgtEl>
-                                        <p:attrNameLst>
-                                          <p:attrName>ppt_x</p:attrName>
-                                        </p:attrNameLst>
-                                      </p:cBhvr>
-                                      <p:tavLst>
-                                        <p:tav tm="0">
-                                          <p:val>
-                                            <p:strVal val="#ppt_x-0.25"/>
-                                          </p:val>
-                                        </p:tav>
-                                        <p:tav tm="100000">
-                                          <p:val>
-                                            <p:strVal val="#ppt_x"/>
-                                          </p:val>
-                                        </p:tav>
-                                      </p:tavLst>
-                                    </p:anim>
-                                    <p:anim calcmode="lin" valueType="num">
-                                      <p:cBhvr>
-                                        <p:cTn id="37" dur="664" tmFilter="0.0,0.0; 0.25,0.07; 0.50,0.2; 0.75,0.467; 1.0,1.0">
-                                          <p:stCondLst>
-                                            <p:cond delay="0"/>
-                                          </p:stCondLst>
-                                        </p:cTn>
-                                        <p:tgtEl>
-                                          <p:spTgt spid="12"/>
-                                        </p:tgtEl>
-                                        <p:attrNameLst>
-                                          <p:attrName>ppt_y</p:attrName>
-                                        </p:attrNameLst>
-                                      </p:cBhvr>
-                                      <p:tavLst>
-                                        <p:tav tm="0" fmla="#ppt_y-sin(pi*$)/3">
-                                          <p:val>
-                                            <p:fltVal val="0.5"/>
-                                          </p:val>
-                                        </p:tav>
-                                        <p:tav tm="100000">
-                                          <p:val>
-                                            <p:fltVal val="1"/>
-                                          </p:val>
-                                        </p:tav>
-                                      </p:tavLst>
-                                    </p:anim>
-                                    <p:anim calcmode="lin" valueType="num">
-                                      <p:cBhvr>
-                                        <p:cTn id="38" dur="664" tmFilter="0, 0; 0.125,0.2665; 0.25,0.4; 0.375,0.465; 0.5,0.5;  0.625,0.535; 0.75,0.6; 0.875,0.7335; 1,1">
-                                          <p:stCondLst>
-                                            <p:cond delay="664"/>
-                                          </p:stCondLst>
-                                        </p:cTn>
-                                        <p:tgtEl>
-                                          <p:spTgt spid="12"/>
-                                        </p:tgtEl>
-                                        <p:attrNameLst>
-                                          <p:attrName>ppt_y</p:attrName>
-                                        </p:attrNameLst>
-                                      </p:cBhvr>
-                                      <p:tavLst>
-                                        <p:tav tm="0" fmla="#ppt_y-sin(pi*$)/9">
-                                          <p:val>
-                                            <p:fltVal val="0"/>
-                                          </p:val>
-                                        </p:tav>
-                                        <p:tav tm="100000">
-                                          <p:val>
-                                            <p:fltVal val="1"/>
-                                          </p:val>
-                                        </p:tav>
-                                      </p:tavLst>
-                                    </p:anim>
-                                    <p:anim calcmode="lin" valueType="num">
-                                      <p:cBhvr>
-                                        <p:cTn id="39" dur="332" tmFilter="0, 0; 0.125,0.2665; 0.25,0.4; 0.375,0.465; 0.5,0.5;  0.625,0.535; 0.75,0.6; 0.875,0.7335; 1,1">
-                                          <p:stCondLst>
-                                            <p:cond delay="1324"/>
-                                          </p:stCondLst>
-                                        </p:cTn>
-                                        <p:tgtEl>
-                                          <p:spTgt spid="12"/>
-                                        </p:tgtEl>
-                                        <p:attrNameLst>
-                                          <p:attrName>ppt_y</p:attrName>
-                                        </p:attrNameLst>
-                                      </p:cBhvr>
-                                      <p:tavLst>
-                                        <p:tav tm="0" fmla="#ppt_y-sin(pi*$)/27">
-                                          <p:val>
-                                            <p:fltVal val="0"/>
-                                          </p:val>
-                                        </p:tav>
-                                        <p:tav tm="100000">
-                                          <p:val>
-                                            <p:fltVal val="1"/>
-                                          </p:val>
-                                        </p:tav>
-                                      </p:tavLst>
-                                    </p:anim>
-                                    <p:anim calcmode="lin" valueType="num">
-                                      <p:cBhvr>
-                                        <p:cTn id="40" dur="164" tmFilter="0, 0; 0.125,0.2665; 0.25,0.4; 0.375,0.465; 0.5,0.5;  0.625,0.535; 0.75,0.6; 0.875,0.7335; 1,1">
-                                          <p:stCondLst>
-                                            <p:cond delay="1656"/>
-                                          </p:stCondLst>
-                                        </p:cTn>
-                                        <p:tgtEl>
-                                          <p:spTgt spid="12"/>
-                                        </p:tgtEl>
-                                        <p:attrNameLst>
-                                          <p:attrName>ppt_y</p:attrName>
-                                        </p:attrNameLst>
-                                      </p:cBhvr>
-                                      <p:tavLst>
-                                        <p:tav tm="0" fmla="#ppt_y-sin(pi*$)/81">
-                                          <p:val>
-                                            <p:fltVal val="0"/>
-                                          </p:val>
-                                        </p:tav>
-                                        <p:tav tm="100000">
-                                          <p:val>
-                                            <p:fltVal val="1"/>
-                                          </p:val>
-                                        </p:tav>
-                                      </p:tavLst>
-                                    </p:anim>
-                                    <p:animScale>
-                                      <p:cBhvr>
-                                        <p:cTn id="41" dur="26">
-                                          <p:stCondLst>
-                                            <p:cond delay="650"/>
-                                          </p:stCondLst>
-                                        </p:cTn>
-                                        <p:tgtEl>
-                                          <p:spTgt spid="12"/>
-                                        </p:tgtEl>
-                                      </p:cBhvr>
-                                      <p:to x="100000" y="60000"/>
-                                    </p:animScale>
-                                    <p:animScale>
-                                      <p:cBhvr>
-                                        <p:cTn id="42" dur="166" decel="50000">
-                                          <p:stCondLst>
-                                            <p:cond delay="676"/>
-                                          </p:stCondLst>
-                                        </p:cTn>
-                                        <p:tgtEl>
-                                          <p:spTgt spid="12"/>
-                                        </p:tgtEl>
-                                      </p:cBhvr>
-                                      <p:to x="100000" y="100000"/>
-                                    </p:animScale>
-                                    <p:animScale>
-                                      <p:cBhvr>
-                                        <p:cTn id="43" dur="26">
-                                          <p:stCondLst>
-                                            <p:cond delay="1312"/>
-                                          </p:stCondLst>
-                                        </p:cTn>
-                                        <p:tgtEl>
-                                          <p:spTgt spid="12"/>
-                                        </p:tgtEl>
-                                      </p:cBhvr>
-                                      <p:to x="100000" y="80000"/>
-                                    </p:animScale>
-                                    <p:animScale>
-                                      <p:cBhvr>
-                                        <p:cTn id="44" dur="166" decel="50000">
-                                          <p:stCondLst>
-                                            <p:cond delay="1338"/>
-                                          </p:stCondLst>
-                                        </p:cTn>
-                                        <p:tgtEl>
-                                          <p:spTgt spid="12"/>
-                                        </p:tgtEl>
-                                      </p:cBhvr>
-                                      <p:to x="100000" y="100000"/>
-                                    </p:animScale>
-                                    <p:animScale>
-                                      <p:cBhvr>
-                                        <p:cTn id="45" dur="26">
-                                          <p:stCondLst>
-                                            <p:cond delay="1642"/>
-                                          </p:stCondLst>
-                                        </p:cTn>
-                                        <p:tgtEl>
-                                          <p:spTgt spid="12"/>
-                                        </p:tgtEl>
-                                      </p:cBhvr>
-                                      <p:to x="100000" y="90000"/>
-                                    </p:animScale>
-                                    <p:animScale>
-                                      <p:cBhvr>
-                                        <p:cTn id="46" dur="166" decel="50000">
-                                          <p:stCondLst>
-                                            <p:cond delay="1668"/>
-                                          </p:stCondLst>
-                                        </p:cTn>
-                                        <p:tgtEl>
-                                          <p:spTgt spid="12"/>
-                                        </p:tgtEl>
-                                      </p:cBhvr>
-                                      <p:to x="100000" y="100000"/>
-                                    </p:animScale>
-                                    <p:animScale>
-                                      <p:cBhvr>
-                                        <p:cTn id="47" dur="26">
-                                          <p:stCondLst>
-                                            <p:cond delay="1808"/>
-                                          </p:stCondLst>
-                                        </p:cTn>
-                                        <p:tgtEl>
-                                          <p:spTgt spid="12"/>
-                                        </p:tgtEl>
-                                      </p:cBhvr>
-                                      <p:to x="100000" y="95000"/>
-                                    </p:animScale>
-                                    <p:animScale>
-                                      <p:cBhvr>
-                                        <p:cTn id="48" dur="166" decel="50000">
-                                          <p:stCondLst>
-                                            <p:cond delay="1834"/>
-                                          </p:stCondLst>
-                                        </p:cTn>
-                                        <p:tgtEl>
-                                          <p:spTgt spid="12"/>
-                                        </p:tgtEl>
-                                      </p:cBhvr>
-                                      <p:to x="100000" y="100000"/>
-                                    </p:animScale>
-                                  </p:childTnLst>
-                                </p:cTn>
-                              </p:par>
-                              <p:par>
-                                <p:cTn id="49" presetID="1" presetClass="entr" presetSubtype="0" fill="hold" nodeType="withEffect">
-                                  <p:stCondLst>
-                                    <p:cond delay="0"/>
-                                  </p:stCondLst>
-                                  <p:childTnLst>
-                                    <p:set>
-                                      <p:cBhvr>
-                                        <p:cTn id="50" dur="1" fill="hold">
-                                          <p:stCondLst>
-                                            <p:cond delay="0"/>
-                                          </p:stCondLst>
-                                        </p:cTn>
-                                        <p:tgtEl>
-                                          <p:spTgt spid="26">
-                                            <p:txEl>
-                                              <p:pRg st="0" end="0"/>
-                                            </p:txEl>
-                                          </p:spTgt>
-                                        </p:tgtEl>
-                                        <p:attrNameLst>
-                                          <p:attrName>style.visibility</p:attrName>
-                                        </p:attrNameLst>
-                                      </p:cBhvr>
-                                      <p:to>
-                                        <p:strVal val="visible"/>
-                                      </p:to>
-                                    </p:set>
-                                  </p:childTnLst>
-                                </p:cTn>
-                              </p:par>
-                            </p:childTnLst>
-                          </p:cTn>
-                        </p:par>
-                      </p:childTnLst>
-                    </p:cTn>
-                  </p:par>
-                  <p:par>
-                    <p:cTn id="51" fill="hold">
-                      <p:stCondLst>
-                        <p:cond delay="indefinite"/>
-                      </p:stCondLst>
-                      <p:childTnLst>
-                        <p:par>
-                          <p:cTn id="52" fill="hold">
-                            <p:stCondLst>
-                              <p:cond delay="0"/>
-                            </p:stCondLst>
-                            <p:childTnLst>
-                              <p:par>
-                                <p:cTn id="53" presetID="53" presetClass="entr" presetSubtype="16" fill="hold" nodeType="clickEffect">
-                                  <p:stCondLst>
-                                    <p:cond delay="0"/>
-                                  </p:stCondLst>
-                                  <p:childTnLst>
-                                    <p:set>
-                                      <p:cBhvr>
-                                        <p:cTn id="54" dur="1" fill="hold">
-                                          <p:stCondLst>
-                                            <p:cond delay="0"/>
-                                          </p:stCondLst>
-                                        </p:cTn>
-                                        <p:tgtEl>
-                                          <p:spTgt spid="20"/>
-                                        </p:tgtEl>
-                                        <p:attrNameLst>
-                                          <p:attrName>style.visibility</p:attrName>
-                                        </p:attrNameLst>
-                                      </p:cBhvr>
-                                      <p:to>
-                                        <p:strVal val="visible"/>
-                                      </p:to>
-                                    </p:set>
-                                    <p:anim calcmode="lin" valueType="num">
-                                      <p:cBhvr>
-                                        <p:cTn id="55" dur="500" fill="hold"/>
-                                        <p:tgtEl>
-                                          <p:spTgt spid="20"/>
-                                        </p:tgtEl>
-                                        <p:attrNameLst>
-                                          <p:attrName>ppt_w</p:attrName>
-                                        </p:attrNameLst>
-                                      </p:cBhvr>
-                                      <p:tavLst>
-                                        <p:tav tm="0">
-                                          <p:val>
-                                            <p:fltVal val="0"/>
-                                          </p:val>
-                                        </p:tav>
-                                        <p:tav tm="100000">
-                                          <p:val>
-                                            <p:strVal val="#ppt_w"/>
-                                          </p:val>
-                                        </p:tav>
-                                      </p:tavLst>
-                                    </p:anim>
-                                    <p:anim calcmode="lin" valueType="num">
-                                      <p:cBhvr>
-                                        <p:cTn id="56" dur="500" fill="hold"/>
-                                        <p:tgtEl>
-                                          <p:spTgt spid="20"/>
-                                        </p:tgtEl>
-                                        <p:attrNameLst>
-                                          <p:attrName>ppt_h</p:attrName>
-                                        </p:attrNameLst>
-                                      </p:cBhvr>
-                                      <p:tavLst>
-                                        <p:tav tm="0">
-                                          <p:val>
-                                            <p:fltVal val="0"/>
-                                          </p:val>
-                                        </p:tav>
-                                        <p:tav tm="100000">
-                                          <p:val>
-                                            <p:strVal val="#ppt_h"/>
-                                          </p:val>
-                                        </p:tav>
-                                      </p:tavLst>
-                                    </p:anim>
-                                    <p:animEffect transition="in" filter="fade">
-                                      <p:cBhvr>
-                                        <p:cTn id="57" dur="500"/>
-                                        <p:tgtEl>
-                                          <p:spTgt spid="20"/>
-                                        </p:tgtEl>
-                                      </p:cBhvr>
-                                    </p:animEffect>
-                                  </p:childTnLst>
-                                </p:cTn>
-                              </p:par>
-                              <p:par>
-                                <p:cTn id="58" presetID="1" presetClass="entr" presetSubtype="0" fill="hold" nodeType="withEffect">
-                                  <p:stCondLst>
-                                    <p:cond delay="0"/>
-                                  </p:stCondLst>
-                                  <p:childTnLst>
-                                    <p:set>
-                                      <p:cBhvr>
-                                        <p:cTn id="59" dur="1" fill="hold">
-                                          <p:stCondLst>
-                                            <p:cond delay="0"/>
-                                          </p:stCondLst>
-                                        </p:cTn>
-                                        <p:tgtEl>
-                                          <p:spTgt spid="27">
-                                            <p:txEl>
-                                              <p:pRg st="0" end="0"/>
-                                            </p:txEl>
-                                          </p:spTgt>
-                                        </p:tgtEl>
-                                        <p:attrNameLst>
-                                          <p:attrName>style.visibility</p:attrName>
-                                        </p:attrNameLst>
-                                      </p:cBhvr>
-                                      <p:to>
-                                        <p:strVal val="visible"/>
-                                      </p:to>
-                                    </p:set>
-                                  </p:childTnLst>
-                                </p:cTn>
-                              </p:par>
-                              <p:par>
-                                <p:cTn id="60" presetID="1" presetClass="entr" presetSubtype="0" fill="hold" nodeType="withEffect">
-                                  <p:stCondLst>
-                                    <p:cond delay="0"/>
-                                  </p:stCondLst>
-                                  <p:childTnLst>
-                                    <p:set>
-                                      <p:cBhvr>
-                                        <p:cTn id="61" dur="1" fill="hold">
+                                        <p:cTn id="11" dur="1" fill="hold">
                                           <p:stCondLst>
                                             <p:cond delay="0"/>
                                           </p:stCondLst>
                                         </p:cTn>
                                         <p:tgtEl>
                                           <p:spTgt spid="8">
-                                            <p:txEl>
-                                              <p:pRg st="0" end="0"/>
-                                            </p:txEl>
-                                          </p:spTgt>
-                                        </p:tgtEl>
-                                        <p:attrNameLst>
-                                          <p:attrName>style.visibility</p:attrName>
-                                        </p:attrNameLst>
-                                      </p:cBhvr>
-                                      <p:to>
-                                        <p:strVal val="visible"/>
-                                      </p:to>
-                                    </p:set>
-                                  </p:childTnLst>
-                                </p:cTn>
-                              </p:par>
-                            </p:childTnLst>
-                          </p:cTn>
-                        </p:par>
-                      </p:childTnLst>
-                    </p:cTn>
-                  </p:par>
-                  <p:par>
-                    <p:cTn id="62" fill="hold">
-                      <p:stCondLst>
-                        <p:cond delay="indefinite"/>
-                      </p:stCondLst>
-                      <p:childTnLst>
-                        <p:par>
-                          <p:cTn id="63" fill="hold">
-                            <p:stCondLst>
-                              <p:cond delay="0"/>
-                            </p:stCondLst>
-                            <p:childTnLst>
-                              <p:par>
-                                <p:cTn id="64" presetID="6" presetClass="entr" presetSubtype="16" fill="hold" nodeType="clickEffect">
-                                  <p:stCondLst>
-                                    <p:cond delay="0"/>
-                                  </p:stCondLst>
-                                  <p:childTnLst>
-                                    <p:set>
-                                      <p:cBhvr>
-                                        <p:cTn id="65" dur="1" fill="hold">
-                                          <p:stCondLst>
-                                            <p:cond delay="0"/>
-                                          </p:stCondLst>
-                                        </p:cTn>
-                                        <p:tgtEl>
-                                          <p:spTgt spid="22"/>
-                                        </p:tgtEl>
-                                        <p:attrNameLst>
-                                          <p:attrName>style.visibility</p:attrName>
-                                        </p:attrNameLst>
-                                      </p:cBhvr>
-                                      <p:to>
-                                        <p:strVal val="visible"/>
-                                      </p:to>
-                                    </p:set>
-                                    <p:animEffect transition="in" filter="circle(in)">
-                                      <p:cBhvr>
-                                        <p:cTn id="66" dur="1000"/>
-                                        <p:tgtEl>
-                                          <p:spTgt spid="22"/>
-                                        </p:tgtEl>
-                                      </p:cBhvr>
-                                    </p:animEffect>
-                                  </p:childTnLst>
-                                </p:cTn>
-                              </p:par>
-                              <p:par>
-                                <p:cTn id="67" presetID="1" presetClass="entr" presetSubtype="0" fill="hold" nodeType="withEffect">
-                                  <p:stCondLst>
-                                    <p:cond delay="0"/>
-                                  </p:stCondLst>
-                                  <p:childTnLst>
-                                    <p:set>
-                                      <p:cBhvr>
-                                        <p:cTn id="68" dur="1" fill="hold">
-                                          <p:stCondLst>
-                                            <p:cond delay="0"/>
-                                          </p:stCondLst>
-                                        </p:cTn>
-                                        <p:tgtEl>
-                                          <p:spTgt spid="14">
                                             <p:txEl>
                                               <p:pRg st="0" end="0"/>
                                             </p:txEl>
@@ -10208,74 +8895,22 @@
           <a:chExt cx="0" cy="0"/>
         </a:xfrm>
       </p:grpSpPr>
-      <p:sp>
-        <p:nvSpPr>
-          <p:cNvPr id="2" name="标题 1">
+      <p:pic>
+        <p:nvPicPr>
+          <p:cNvPr id="4" name="内容占位符 4">
             <a:extLst>
               <a:ext uri="{FF2B5EF4-FFF2-40B4-BE49-F238E27FC236}">
-                <a16:creationId xmlns:a16="http://schemas.microsoft.com/office/drawing/2014/main" id="{1C57BB4F-4FD1-8611-9FF5-DFD975CEA7C9}"/>
-              </a:ext>
-            </a:extLst>
-          </p:cNvPr>
-          <p:cNvSpPr>
-            <a:spLocks noGrp="1"/>
-          </p:cNvSpPr>
-          <p:nvPr>
-            <p:ph type="title"/>
-          </p:nvPr>
-        </p:nvSpPr>
-        <p:spPr/>
-        <p:txBody>
-          <a:bodyPr/>
-          <a:lstStyle/>
-          <a:p>
-            <a:endParaRPr lang="zh-CN" altLang="en-US"/>
-          </a:p>
-        </p:txBody>
-      </p:sp>
-      <p:sp>
-        <p:nvSpPr>
-          <p:cNvPr id="3" name="文本占位符 2">
-            <a:extLst>
-              <a:ext uri="{FF2B5EF4-FFF2-40B4-BE49-F238E27FC236}">
-                <a16:creationId xmlns:a16="http://schemas.microsoft.com/office/drawing/2014/main" id="{C33C9FC0-29AF-241D-80C9-1E13F45880B6}"/>
-              </a:ext>
-            </a:extLst>
-          </p:cNvPr>
-          <p:cNvSpPr>
-            <a:spLocks noGrp="1"/>
-          </p:cNvSpPr>
-          <p:nvPr>
-            <p:ph type="body" idx="1"/>
-          </p:nvPr>
-        </p:nvSpPr>
-        <p:spPr/>
-        <p:txBody>
-          <a:bodyPr/>
-          <a:lstStyle/>
-          <a:p>
-            <a:endParaRPr lang="zh-CN" altLang="en-US"/>
-          </a:p>
-        </p:txBody>
-      </p:sp>
-      <p:pic>
-        <p:nvPicPr>
-          <p:cNvPr id="8" name="内容占位符 7">
-            <a:extLst>
-              <a:ext uri="{FF2B5EF4-FFF2-40B4-BE49-F238E27FC236}">
-                <a16:creationId xmlns:a16="http://schemas.microsoft.com/office/drawing/2014/main" id="{1A153594-4E83-1AE7-6987-E23EA844091B}"/>
+                <a16:creationId xmlns:a16="http://schemas.microsoft.com/office/drawing/2014/main" id="{F1F10959-072B-9998-0FDE-18AD6267E91C}"/>
               </a:ext>
             </a:extLst>
           </p:cNvPr>
           <p:cNvPicPr>
-            <a:picLocks noGrp="1" noChangeAspect="1"/>
+            <a:picLocks noChangeAspect="1"/>
           </p:cNvPicPr>
-          <p:nvPr>
-            <p:ph sz="half" idx="2"/>
-          </p:nvPr>
+          <p:nvPr/>
         </p:nvPicPr>
         <p:blipFill>
-          <a:blip r:embed="rId3">
+          <a:blip r:embed="rId2">
             <a:extLst>
               <a:ext uri="{28A0092B-C50C-407E-A947-70E740481C1C}">
                 <a14:useLocalDpi xmlns:a14="http://schemas.microsoft.com/office/drawing/2010/main" val="0"/>
@@ -10288,101 +8923,158 @@
         </p:blipFill>
         <p:spPr>
           <a:xfrm>
-            <a:off x="0" y="-1488"/>
-            <a:ext cx="12192000" cy="6859488"/>
+            <a:off x="6096000" y="689445"/>
+            <a:ext cx="5056405" cy="2739555"/>
           </a:xfrm>
+          <a:prstGeom prst="rect">
+            <a:avLst/>
+          </a:prstGeom>
         </p:spPr>
       </p:pic>
       <p:sp>
         <p:nvSpPr>
-          <p:cNvPr id="5" name="文本占位符 4">
+          <p:cNvPr id="5" name="文本框 4">
             <a:extLst>
               <a:ext uri="{FF2B5EF4-FFF2-40B4-BE49-F238E27FC236}">
-                <a16:creationId xmlns:a16="http://schemas.microsoft.com/office/drawing/2014/main" id="{193BAE65-F89D-04AA-78D6-8B4DA240C250}"/>
+                <a16:creationId xmlns:a16="http://schemas.microsoft.com/office/drawing/2014/main" id="{821492F8-6AA1-D18F-8F82-A88EB1720CCC}"/>
               </a:ext>
             </a:extLst>
           </p:cNvPr>
-          <p:cNvSpPr>
-            <a:spLocks noGrp="1"/>
-          </p:cNvSpPr>
-          <p:nvPr>
-            <p:ph type="body" sz="quarter" idx="3"/>
-          </p:nvPr>
+          <p:cNvSpPr txBox="1"/>
+          <p:nvPr/>
         </p:nvSpPr>
         <p:spPr>
           <a:xfrm>
-            <a:off x="2933104" y="5078435"/>
-            <a:ext cx="7289888" cy="576262"/>
+            <a:off x="583008" y="3768064"/>
+            <a:ext cx="10463436" cy="2308324"/>
           </a:xfrm>
+          <a:prstGeom prst="rect">
+            <a:avLst/>
+          </a:prstGeom>
+          <a:noFill/>
         </p:spPr>
         <p:txBody>
-          <a:bodyPr/>
+          <a:bodyPr wrap="square" rtlCol="0">
+            <a:spAutoFit/>
+          </a:bodyPr>
           <a:lstStyle/>
           <a:p>
             <a:r>
-              <a:rPr lang="zh-CN" altLang="en-US" sz="6000" dirty="0">
-                <a:latin typeface="方正姚体" panose="02010601030101010101" pitchFamily="2" charset="-122"/>
-                <a:ea typeface="方正姚体" panose="02010601030101010101" pitchFamily="2" charset="-122"/>
-              </a:rPr>
-              <a:t>看到这里还不鼓掌</a:t>
-            </a:r>
-          </a:p>
-        </p:txBody>
-      </p:sp>
-      <p:sp>
-        <p:nvSpPr>
-          <p:cNvPr id="6" name="内容占位符 5">
+              <a:rPr lang="zh-CN" altLang="zh-CN" sz="2400" dirty="0"/>
+              <a:t>这幅画代表新中国美术发展。董希文三进西藏写生，积累素材。他以朴素画风表现西藏农奴翻身做主，在土地上耕耘的喜悦。</a:t>
+            </a:r>
+          </a:p>
+          <a:p>
+            <a:r>
+              <a:rPr lang="zh-CN" altLang="zh-CN" sz="2400" dirty="0"/>
+              <a:t>画面充满动感。人物后仰，牦牛奋蹄，笔触方向一致。雪山蓝天带来不一样的春天。</a:t>
+            </a:r>
+          </a:p>
+          <a:p>
+            <a:r>
+              <a:rPr lang="zh-CN" altLang="zh-CN" sz="2400" dirty="0"/>
+              <a:t>对角线构图和桃红上衣与左下阴影对比。这表现出高原阳光，也表现出人物内心的激动喜悦。</a:t>
+            </a:r>
+          </a:p>
+        </p:txBody>
+      </p:sp>
+      <p:sp>
+        <p:nvSpPr>
+          <p:cNvPr id="6" name="文本框 5">
             <a:extLst>
               <a:ext uri="{FF2B5EF4-FFF2-40B4-BE49-F238E27FC236}">
-                <a16:creationId xmlns:a16="http://schemas.microsoft.com/office/drawing/2014/main" id="{55E49F84-00E6-CFE9-D420-1F5307A0BCB9}"/>
+                <a16:creationId xmlns:a16="http://schemas.microsoft.com/office/drawing/2014/main" id="{8A55A1E2-AE62-3EE2-1327-0CF927CE7833}"/>
               </a:ext>
             </a:extLst>
           </p:cNvPr>
-          <p:cNvSpPr>
-            <a:spLocks noGrp="1"/>
-          </p:cNvSpPr>
-          <p:nvPr>
-            <p:ph sz="quarter" idx="4"/>
-          </p:nvPr>
+          <p:cNvSpPr txBox="1"/>
+          <p:nvPr/>
         </p:nvSpPr>
         <p:spPr>
           <a:xfrm>
-            <a:off x="1639646" y="1203303"/>
-            <a:ext cx="8912707" cy="3638551"/>
+            <a:off x="441859" y="997393"/>
+            <a:ext cx="5512992" cy="2123658"/>
           </a:xfrm>
+          <a:prstGeom prst="rect">
+            <a:avLst/>
+          </a:prstGeom>
+          <a:noFill/>
         </p:spPr>
         <p:txBody>
-          <a:bodyPr>
-            <a:normAutofit/>
+          <a:bodyPr wrap="square" rtlCol="0">
+            <a:spAutoFit/>
           </a:bodyPr>
           <a:lstStyle/>
           <a:p>
-            <a:pPr marL="0" indent="0">
-              <a:buNone/>
-            </a:pPr>
-            <a:r>
-              <a:rPr lang="zh-CN" altLang="en-US" sz="6600" dirty="0"/>
-              <a:t>           感谢观看</a:t>
-            </a:r>
-          </a:p>
-        </p:txBody>
-      </p:sp>
+            <a:r>
+              <a:rPr lang="en-US" altLang="zh-CN" sz="3600" dirty="0"/>
+              <a:t>《</a:t>
+            </a:r>
+            <a:r>
+              <a:rPr lang="zh-CN" altLang="zh-CN" sz="3600" dirty="0"/>
+              <a:t>千年土地翻了身》</a:t>
+            </a:r>
+            <a:endParaRPr lang="en-US" altLang="zh-CN" sz="3600" dirty="0"/>
+          </a:p>
+          <a:p>
+            <a:r>
+              <a:rPr lang="zh-CN" altLang="zh-CN" sz="3200" dirty="0"/>
+              <a:t>是董希文1963年油画，藏中国美术馆。</a:t>
+            </a:r>
+          </a:p>
+          <a:p>
+            <a:endParaRPr lang="zh-CN" altLang="en-US" sz="3200" dirty="0"/>
+          </a:p>
+        </p:txBody>
+      </p:sp>
+    </p:spTree>
+    <p:extLst>
+      <p:ext uri="{BB962C8B-B14F-4D97-AF65-F5344CB8AC3E}">
+        <p14:creationId xmlns:p14="http://schemas.microsoft.com/office/powerpoint/2010/main" val="2389299759"/>
+      </p:ext>
+    </p:extLst>
+  </p:cSld>
+  <p:clrMapOvr>
+    <a:masterClrMapping/>
+  </p:clrMapOvr>
+</p:sld>
+</file>
+
+<file path=ppt/slides/slide4.xml><?xml version="1.0" encoding="utf-8"?>
+<p:sld xmlns:a="http://schemas.openxmlformats.org/drawingml/2006/main" xmlns:r="http://schemas.openxmlformats.org/officeDocument/2006/relationships" xmlns:p="http://schemas.openxmlformats.org/presentationml/2006/main">
+  <p:cSld>
+    <p:spTree>
+      <p:nvGrpSpPr>
+        <p:cNvPr id="1" name=""/>
+        <p:cNvGrpSpPr/>
+        <p:nvPr/>
+      </p:nvGrpSpPr>
+      <p:grpSpPr>
+        <a:xfrm>
+          <a:off x="0" y="0"/>
+          <a:ext cx="0" cy="0"/>
+          <a:chOff x="0" y="0"/>
+          <a:chExt cx="0" cy="0"/>
+        </a:xfrm>
+      </p:grpSpPr>
       <p:pic>
         <p:nvPicPr>
-          <p:cNvPr id="10" name="图片 9">
+          <p:cNvPr id="5" name="内容占位符 4">
             <a:extLst>
               <a:ext uri="{FF2B5EF4-FFF2-40B4-BE49-F238E27FC236}">
-                <a16:creationId xmlns:a16="http://schemas.microsoft.com/office/drawing/2014/main" id="{F0D1E608-56A9-C746-D300-A8D50650F71A}"/>
+                <a16:creationId xmlns:a16="http://schemas.microsoft.com/office/drawing/2014/main" id="{77FF67A5-5561-865C-2DC8-2F112596DED5}"/>
               </a:ext>
             </a:extLst>
           </p:cNvPr>
           <p:cNvPicPr>
-            <a:picLocks noChangeAspect="1"/>
+            <a:picLocks noGrp="1" noChangeAspect="1"/>
           </p:cNvPicPr>
-          <p:nvPr/>
+          <p:nvPr>
+            <p:ph idx="1"/>
+          </p:nvPr>
         </p:nvPicPr>
         <p:blipFill>
-          <a:blip r:embed="rId4">
+          <a:blip r:embed="rId2">
             <a:extLst>
               <a:ext uri="{28A0092B-C50C-407E-A947-70E740481C1C}">
                 <a14:useLocalDpi xmlns:a14="http://schemas.microsoft.com/office/drawing/2010/main" val="0"/>
@@ -10395,14 +9087,289 @@
         </p:blipFill>
         <p:spPr>
           <a:xfrm>
-            <a:off x="684531" y="3022578"/>
-            <a:ext cx="2857500" cy="2857500"/>
+            <a:off x="0" y="126193"/>
+            <a:ext cx="12192000" cy="6605613"/>
           </a:xfrm>
           <a:prstGeom prst="rect">
             <a:avLst/>
           </a:prstGeom>
         </p:spPr>
       </p:pic>
+    </p:spTree>
+    <p:extLst>
+      <p:ext uri="{BB962C8B-B14F-4D97-AF65-F5344CB8AC3E}">
+        <p14:creationId xmlns:p14="http://schemas.microsoft.com/office/powerpoint/2010/main" val="4022660133"/>
+      </p:ext>
+    </p:extLst>
+  </p:cSld>
+  <p:clrMapOvr>
+    <a:masterClrMapping/>
+  </p:clrMapOvr>
+</p:sld>
+</file>
+
+<file path=ppt/slides/slide5.xml><?xml version="1.0" encoding="utf-8"?>
+<p:sld xmlns:a="http://schemas.openxmlformats.org/drawingml/2006/main" xmlns:r="http://schemas.openxmlformats.org/officeDocument/2006/relationships" xmlns:p="http://schemas.openxmlformats.org/presentationml/2006/main">
+  <p:cSld>
+    <p:spTree>
+      <p:nvGrpSpPr>
+        <p:cNvPr id="1" name=""/>
+        <p:cNvGrpSpPr/>
+        <p:nvPr/>
+      </p:nvGrpSpPr>
+      <p:grpSpPr>
+        <a:xfrm>
+          <a:off x="0" y="0"/>
+          <a:ext cx="0" cy="0"/>
+          <a:chOff x="0" y="0"/>
+          <a:chExt cx="0" cy="0"/>
+        </a:xfrm>
+      </p:grpSpPr>
+      <p:sp>
+        <p:nvSpPr>
+          <p:cNvPr id="2" name="标题 1">
+            <a:extLst>
+              <a:ext uri="{FF2B5EF4-FFF2-40B4-BE49-F238E27FC236}">
+                <a16:creationId xmlns:a16="http://schemas.microsoft.com/office/drawing/2014/main" id="{CA7E1906-88E4-8131-68C3-97518B225D1E}"/>
+              </a:ext>
+            </a:extLst>
+          </p:cNvPr>
+          <p:cNvSpPr>
+            <a:spLocks noGrp="1"/>
+          </p:cNvSpPr>
+          <p:nvPr>
+            <p:ph type="title"/>
+          </p:nvPr>
+        </p:nvSpPr>
+        <p:spPr>
+          <a:xfrm>
+            <a:off x="707009" y="3784861"/>
+            <a:ext cx="11170763" cy="2832756"/>
+          </a:xfrm>
+        </p:spPr>
+        <p:txBody>
+          <a:bodyPr>
+            <a:normAutofit fontScale="90000"/>
+          </a:bodyPr>
+          <a:lstStyle/>
+          <a:p>
+            <a:r>
+              <a:rPr lang="zh-CN" altLang="zh-CN" sz="3200" dirty="0"/>
+              <a:t>1.感谢</a:t>
+            </a:r>
+            <a:r>
+              <a:rPr lang="zh-CN" altLang="zh-CN" sz="3200" dirty="0">
+                <a:highlight>
+                  <a:srgbClr val="00FFFF"/>
+                </a:highlight>
+              </a:rPr>
+              <a:t>美术教材</a:t>
+            </a:r>
+            <a:r>
+              <a:rPr lang="zh-CN" altLang="zh-CN" sz="3200" dirty="0"/>
+              <a:t>催生了这个</a:t>
+            </a:r>
+            <a:r>
+              <a:rPr lang="zh-CN" altLang="zh-CN" sz="3200" dirty="0">
+                <a:highlight>
+                  <a:srgbClr val="00FFFF"/>
+                </a:highlight>
+              </a:rPr>
+              <a:t>PPT</a:t>
+            </a:r>
+            <a:r>
+              <a:rPr lang="zh-CN" altLang="zh-CN" sz="3200" dirty="0"/>
+              <a:t>。</a:t>
+            </a:r>
+            <a:br>
+              <a:rPr lang="en-US" altLang="zh-CN" sz="3200" dirty="0"/>
+            </a:br>
+            <a:r>
+              <a:rPr lang="en-US" altLang="zh-CN" sz="3200" dirty="0"/>
+              <a:t>2.</a:t>
+            </a:r>
+            <a:r>
+              <a:rPr lang="zh-CN" altLang="zh-CN" sz="2800" dirty="0"/>
+              <a:t>感谢</a:t>
+            </a:r>
+            <a:r>
+              <a:rPr lang="zh-CN" altLang="zh-CN" sz="2800" dirty="0">
+                <a:highlight>
+                  <a:srgbClr val="00FFFF"/>
+                </a:highlight>
+              </a:rPr>
+              <a:t>deepseek</a:t>
+            </a:r>
+            <a:r>
+              <a:rPr lang="zh-CN" altLang="zh-CN" sz="2800" dirty="0"/>
+              <a:t>提供了免费的文本编写服务。</a:t>
+            </a:r>
+            <a:br>
+              <a:rPr lang="zh-CN" altLang="zh-CN" sz="3200" dirty="0"/>
+            </a:br>
+            <a:r>
+              <a:rPr lang="en-US" altLang="zh-CN" sz="3200" dirty="0"/>
+              <a:t>3</a:t>
+            </a:r>
+            <a:r>
+              <a:rPr lang="zh-CN" altLang="zh-CN" sz="3200" dirty="0"/>
+              <a:t>.感谢</a:t>
+            </a:r>
+            <a:r>
+              <a:rPr lang="zh-CN" altLang="zh-CN" sz="3200" dirty="0">
+                <a:highlight>
+                  <a:srgbClr val="00FFFF"/>
+                </a:highlight>
+              </a:rPr>
+              <a:t>千问</a:t>
+            </a:r>
+            <a:r>
+              <a:rPr lang="zh-CN" altLang="zh-CN" sz="3200" dirty="0"/>
+              <a:t>提供了免费的 </a:t>
+            </a:r>
+            <a:r>
+              <a:rPr lang="zh-CN" altLang="zh-CN" sz="3200" dirty="0">
+                <a:highlight>
+                  <a:srgbClr val="00FFFF"/>
+                </a:highlight>
+              </a:rPr>
+              <a:t>AI</a:t>
+            </a:r>
+            <a:r>
+              <a:rPr lang="zh-CN" altLang="zh-CN" sz="3200" dirty="0"/>
+              <a:t> 图片清晰度提升服务。</a:t>
+            </a:r>
+            <a:br>
+              <a:rPr lang="zh-CN" altLang="zh-CN" sz="3200" dirty="0"/>
+            </a:br>
+            <a:r>
+              <a:rPr lang="en-US" altLang="zh-CN" sz="3200" dirty="0"/>
+              <a:t>4.</a:t>
+            </a:r>
+            <a:r>
+              <a:rPr lang="zh-CN" altLang="zh-CN" dirty="0"/>
+              <a:t>感谢</a:t>
+            </a:r>
+            <a:r>
+              <a:rPr lang="zh-CN" altLang="zh-CN" dirty="0">
+                <a:highlight>
+                  <a:srgbClr val="00FFFF"/>
+                </a:highlight>
+              </a:rPr>
+              <a:t>中国美术馆网站</a:t>
+            </a:r>
+            <a:r>
+              <a:rPr lang="zh-CN" altLang="zh-CN" dirty="0"/>
+              <a:t>提供了油画照片</a:t>
+            </a:r>
+            <a:br>
+              <a:rPr lang="en-US" altLang="zh-CN" sz="3200" dirty="0"/>
+            </a:br>
+            <a:r>
+              <a:rPr lang="en-US" altLang="zh-CN" sz="3200" dirty="0"/>
+              <a:t>5</a:t>
+            </a:r>
+            <a:r>
+              <a:rPr lang="zh-CN" altLang="zh-CN" sz="3200" dirty="0"/>
+              <a:t>.感谢我们的</a:t>
+            </a:r>
+            <a:r>
+              <a:rPr lang="zh-CN" altLang="zh-CN" sz="3200" dirty="0">
+                <a:highlight>
+                  <a:srgbClr val="00FFFF"/>
+                </a:highlight>
+              </a:rPr>
+              <a:t>美术老师</a:t>
+            </a:r>
+            <a:r>
+              <a:rPr lang="zh-CN" altLang="zh-CN" sz="3200" dirty="0"/>
+              <a:t>让我们完成了这个</a:t>
+            </a:r>
+            <a:r>
+              <a:rPr lang="zh-CN" altLang="zh-CN" sz="3200" dirty="0">
+                <a:highlight>
+                  <a:srgbClr val="00FFFF"/>
+                </a:highlight>
+              </a:rPr>
+              <a:t>PPT</a:t>
+            </a:r>
+            <a:r>
+              <a:rPr lang="zh-CN" altLang="zh-CN" sz="3200" dirty="0"/>
+              <a:t>。</a:t>
+            </a:r>
+            <a:br>
+              <a:rPr lang="zh-CN" altLang="zh-CN" sz="3200" dirty="0"/>
+            </a:br>
+            <a:r>
+              <a:rPr lang="en-US" altLang="zh-CN" sz="3200" dirty="0"/>
+              <a:t>6</a:t>
+            </a:r>
+            <a:r>
+              <a:rPr lang="zh-CN" altLang="zh-CN" sz="3200" dirty="0"/>
+              <a:t>.感谢你</a:t>
+            </a:r>
+            <a:r>
+              <a:rPr lang="zh-CN" altLang="en-US" sz="3200" dirty="0"/>
+              <a:t>的观看</a:t>
+            </a:r>
+            <a:r>
+              <a:rPr lang="zh-CN" altLang="zh-CN" sz="3200" dirty="0"/>
+              <a:t>——让这个</a:t>
+            </a:r>
+            <a:r>
+              <a:rPr lang="zh-CN" altLang="zh-CN" sz="3200" dirty="0">
+                <a:highlight>
+                  <a:srgbClr val="00FFFF"/>
+                </a:highlight>
+              </a:rPr>
+              <a:t>PPT</a:t>
+            </a:r>
+            <a:r>
+              <a:rPr lang="zh-CN" altLang="zh-CN" sz="3200" dirty="0"/>
+              <a:t>有了存在的意义。</a:t>
+            </a:r>
+            <a:br>
+              <a:rPr lang="zh-CN" altLang="zh-CN" sz="2800" dirty="0"/>
+            </a:br>
+            <a:endParaRPr lang="zh-CN" altLang="en-US" sz="2800" dirty="0"/>
+          </a:p>
+        </p:txBody>
+      </p:sp>
+      <p:sp>
+        <p:nvSpPr>
+          <p:cNvPr id="5" name="文本框 4">
+            <a:extLst>
+              <a:ext uri="{FF2B5EF4-FFF2-40B4-BE49-F238E27FC236}">
+                <a16:creationId xmlns:a16="http://schemas.microsoft.com/office/drawing/2014/main" id="{65593A91-EA66-1E7A-5CE1-792CB333672E}"/>
+              </a:ext>
+            </a:extLst>
+          </p:cNvPr>
+          <p:cNvSpPr txBox="1"/>
+          <p:nvPr/>
+        </p:nvSpPr>
+        <p:spPr>
+          <a:xfrm>
+            <a:off x="707009" y="2889337"/>
+            <a:ext cx="1338606" cy="769441"/>
+          </a:xfrm>
+          <a:prstGeom prst="rect">
+            <a:avLst/>
+          </a:prstGeom>
+          <a:noFill/>
+        </p:spPr>
+        <p:txBody>
+          <a:bodyPr wrap="square" rtlCol="0">
+            <a:spAutoFit/>
+          </a:bodyPr>
+          <a:lstStyle/>
+          <a:p>
+            <a:r>
+              <a:rPr lang="zh-CN" altLang="en-US" sz="4400" dirty="0"/>
+              <a:t>鸣谢</a:t>
+            </a:r>
+          </a:p>
+        </p:txBody>
+      </p:sp>
       <p:pic>
         <p:nvPicPr>
           <p:cNvPr id="12" name="图片 11">
@@ -10418,43 +9385,7 @@
           <p:nvPr/>
         </p:nvPicPr>
         <p:blipFill>
-          <a:blip r:embed="rId4">
-            <a:extLst>
-              <a:ext uri="{28A0092B-C50C-407E-A947-70E740481C1C}">
-                <a14:useLocalDpi xmlns:a14="http://schemas.microsoft.com/office/drawing/2010/main" val="0"/>
-              </a:ext>
-            </a:extLst>
-          </a:blip>
-          <a:stretch>
-            <a:fillRect/>
-          </a:stretch>
-        </p:blipFill>
-        <p:spPr>
-          <a:xfrm flipH="1">
-            <a:off x="8647111" y="3022578"/>
-            <a:ext cx="2857500" cy="2857500"/>
-          </a:xfrm>
-          <a:prstGeom prst="rect">
-            <a:avLst/>
-          </a:prstGeom>
-        </p:spPr>
-      </p:pic>
-      <p:pic>
-        <p:nvPicPr>
-          <p:cNvPr id="14" name="图片 13">
-            <a:extLst>
-              <a:ext uri="{FF2B5EF4-FFF2-40B4-BE49-F238E27FC236}">
-                <a16:creationId xmlns:a16="http://schemas.microsoft.com/office/drawing/2014/main" id="{FF49C79F-65E0-EA85-14BC-D53AE47EA50B}"/>
-              </a:ext>
-            </a:extLst>
-          </p:cNvPr>
-          <p:cNvPicPr>
-            <a:picLocks noChangeAspect="1"/>
-          </p:cNvPicPr>
-          <p:nvPr/>
-        </p:nvPicPr>
-        <p:blipFill>
-          <a:blip r:embed="rId5">
+          <a:blip r:embed="rId2">
             <a:extLst>
               <a:ext uri="{28A0092B-C50C-407E-A947-70E740481C1C}">
                 <a14:useLocalDpi xmlns:a14="http://schemas.microsoft.com/office/drawing/2010/main" val="0"/>
@@ -10467,36 +9398,605 @@
         </p:blipFill>
         <p:spPr>
           <a:xfrm>
-            <a:off x="4646105" y="3166036"/>
-            <a:ext cx="2286000" cy="2286000"/>
+            <a:off x="707009" y="497679"/>
+            <a:ext cx="2265575" cy="2265575"/>
           </a:xfrm>
           <a:prstGeom prst="rect">
             <a:avLst/>
           </a:prstGeom>
         </p:spPr>
       </p:pic>
+      <p:graphicFrame>
+        <p:nvGraphicFramePr>
+          <p:cNvPr id="7" name="表格 6">
+            <a:extLst>
+              <a:ext uri="{FF2B5EF4-FFF2-40B4-BE49-F238E27FC236}">
+                <a16:creationId xmlns:a16="http://schemas.microsoft.com/office/drawing/2014/main" id="{03E353EF-1F9C-4AEB-405D-A05F4CB915F0}"/>
+              </a:ext>
+            </a:extLst>
+          </p:cNvPr>
+          <p:cNvGraphicFramePr>
+            <a:graphicFrameLocks noGrp="1"/>
+          </p:cNvGraphicFramePr>
+          <p:nvPr>
+            <p:extLst>
+              <p:ext uri="{D42A27DB-BD31-4B8C-83A1-F6EECF244321}">
+                <p14:modId xmlns:p14="http://schemas.microsoft.com/office/powerpoint/2010/main" val="3858190212"/>
+              </p:ext>
+            </p:extLst>
+          </p:nvPr>
+        </p:nvGraphicFramePr>
+        <p:xfrm>
+          <a:off x="6096000" y="366107"/>
+          <a:ext cx="5576347" cy="3418754"/>
+        </p:xfrm>
+        <a:graphic>
+          <a:graphicData uri="http://schemas.openxmlformats.org/drawingml/2006/table">
+            <a:tbl>
+              <a:tblPr>
+                <a:tableStyleId>{5940675A-B579-460E-94D1-54222C63F5DA}</a:tableStyleId>
+              </a:tblPr>
+              <a:tblGrid>
+                <a:gridCol w="1280105">
+                  <a:extLst>
+                    <a:ext uri="{9D8B030D-6E8A-4147-A177-3AD203B41FA5}">
+                      <a16:colId xmlns:a16="http://schemas.microsoft.com/office/drawing/2014/main" val="3207987399"/>
+                    </a:ext>
+                  </a:extLst>
+                </a:gridCol>
+                <a:gridCol w="4296242">
+                  <a:extLst>
+                    <a:ext uri="{9D8B030D-6E8A-4147-A177-3AD203B41FA5}">
+                      <a16:colId xmlns:a16="http://schemas.microsoft.com/office/drawing/2014/main" val="2456620992"/>
+                    </a:ext>
+                  </a:extLst>
+                </a:gridCol>
+              </a:tblGrid>
+              <a:tr h="357760">
+                <a:tc>
+                  <a:txBody>
+                    <a:bodyPr/>
+                    <a:lstStyle/>
+                    <a:p>
+                      <a:pPr algn="ctr" fontAlgn="t">
+                        <a:buNone/>
+                      </a:pPr>
+                      <a:r>
+                        <a:rPr lang="zh-CN" sz="1600" u="none" strike="noStrike">
+                          <a:effectLst/>
+                        </a:rPr>
+                        <a:t>姓名</a:t>
+                      </a:r>
+                      <a:endParaRPr lang="zh-CN" sz="1600" b="0" i="0" u="none" strike="noStrike">
+                        <a:solidFill>
+                          <a:srgbClr val="000000"/>
+                        </a:solidFill>
+                        <a:effectLst/>
+                        <a:latin typeface="等线" panose="02010600030101010101" pitchFamily="2" charset="-122"/>
+                        <a:ea typeface="等线" panose="02010600030101010101" pitchFamily="2" charset="-122"/>
+                      </a:endParaRPr>
+                    </a:p>
+                  </a:txBody>
+                  <a:tcPr marL="6350" marR="6350" marT="6350" marB="0"/>
+                </a:tc>
+                <a:tc>
+                  <a:txBody>
+                    <a:bodyPr/>
+                    <a:lstStyle/>
+                    <a:p>
+                      <a:pPr algn="ctr" fontAlgn="t">
+                        <a:buNone/>
+                      </a:pPr>
+                      <a:r>
+                        <a:rPr lang="zh-CN" sz="1600" u="none" strike="noStrike">
+                          <a:effectLst/>
+                        </a:rPr>
+                        <a:t>职能</a:t>
+                      </a:r>
+                      <a:endParaRPr lang="zh-CN" sz="1600" b="0" i="0" u="none" strike="noStrike">
+                        <a:solidFill>
+                          <a:srgbClr val="000000"/>
+                        </a:solidFill>
+                        <a:effectLst/>
+                        <a:latin typeface="等线" panose="02010600030101010101" pitchFamily="2" charset="-122"/>
+                        <a:ea typeface="等线" panose="02010600030101010101" pitchFamily="2" charset="-122"/>
+                      </a:endParaRPr>
+                    </a:p>
+                  </a:txBody>
+                  <a:tcPr marL="6350" marR="6350" marT="6350" marB="0"/>
+                </a:tc>
+                <a:extLst>
+                  <a:ext uri="{0D108BD9-81ED-4DB2-BD59-A6C34878D82A}">
+                    <a16:rowId xmlns:a16="http://schemas.microsoft.com/office/drawing/2014/main" val="670625170"/>
+                  </a:ext>
+                </a:extLst>
+              </a:tr>
+              <a:tr h="357760">
+                <a:tc>
+                  <a:txBody>
+                    <a:bodyPr/>
+                    <a:lstStyle/>
+                    <a:p>
+                      <a:pPr algn="ctr" fontAlgn="t">
+                        <a:buNone/>
+                      </a:pPr>
+                      <a:r>
+                        <a:rPr lang="zh-CN" sz="1600" u="none" strike="noStrike">
+                          <a:effectLst/>
+                        </a:rPr>
+                        <a:t>王语涵</a:t>
+                      </a:r>
+                      <a:endParaRPr lang="zh-CN" sz="1600" b="0" i="0" u="none" strike="noStrike">
+                        <a:solidFill>
+                          <a:srgbClr val="000000"/>
+                        </a:solidFill>
+                        <a:effectLst/>
+                        <a:latin typeface="等线" panose="02010600030101010101" pitchFamily="2" charset="-122"/>
+                        <a:ea typeface="等线" panose="02010600030101010101" pitchFamily="2" charset="-122"/>
+                      </a:endParaRPr>
+                    </a:p>
+                  </a:txBody>
+                  <a:tcPr marL="6350" marR="6350" marT="6350" marB="0"/>
+                </a:tc>
+                <a:tc>
+                  <a:txBody>
+                    <a:bodyPr/>
+                    <a:lstStyle/>
+                    <a:p>
+                      <a:pPr algn="ctr" fontAlgn="t">
+                        <a:buNone/>
+                      </a:pPr>
+                      <a:r>
+                        <a:rPr lang="zh-CN" sz="1600" u="none" strike="noStrike">
+                          <a:effectLst/>
+                        </a:rPr>
+                        <a:t>旁白</a:t>
+                      </a:r>
+                      <a:endParaRPr lang="zh-CN" sz="1600" b="0" i="0" u="none" strike="noStrike">
+                        <a:solidFill>
+                          <a:srgbClr val="000000"/>
+                        </a:solidFill>
+                        <a:effectLst/>
+                        <a:latin typeface="等线" panose="02010600030101010101" pitchFamily="2" charset="-122"/>
+                        <a:ea typeface="等线" panose="02010600030101010101" pitchFamily="2" charset="-122"/>
+                      </a:endParaRPr>
+                    </a:p>
+                  </a:txBody>
+                  <a:tcPr marL="6350" marR="6350" marT="6350" marB="0"/>
+                </a:tc>
+                <a:extLst>
+                  <a:ext uri="{0D108BD9-81ED-4DB2-BD59-A6C34878D82A}">
+                    <a16:rowId xmlns:a16="http://schemas.microsoft.com/office/drawing/2014/main" val="756411464"/>
+                  </a:ext>
+                </a:extLst>
+              </a:tr>
+              <a:tr h="357760">
+                <a:tc>
+                  <a:txBody>
+                    <a:bodyPr/>
+                    <a:lstStyle/>
+                    <a:p>
+                      <a:pPr algn="ctr" fontAlgn="t">
+                        <a:buNone/>
+                      </a:pPr>
+                      <a:r>
+                        <a:rPr lang="zh-CN" sz="1600" u="none" strike="noStrike">
+                          <a:effectLst/>
+                        </a:rPr>
+                        <a:t>邵炜雅</a:t>
+                      </a:r>
+                      <a:endParaRPr lang="zh-CN" sz="1600" b="0" i="0" u="none" strike="noStrike">
+                        <a:solidFill>
+                          <a:srgbClr val="000000"/>
+                        </a:solidFill>
+                        <a:effectLst/>
+                        <a:latin typeface="等线" panose="02010600030101010101" pitchFamily="2" charset="-122"/>
+                        <a:ea typeface="等线" panose="02010600030101010101" pitchFamily="2" charset="-122"/>
+                      </a:endParaRPr>
+                    </a:p>
+                  </a:txBody>
+                  <a:tcPr marL="6350" marR="6350" marT="6350" marB="0"/>
+                </a:tc>
+                <a:tc>
+                  <a:txBody>
+                    <a:bodyPr/>
+                    <a:lstStyle/>
+                    <a:p>
+                      <a:pPr algn="ctr" fontAlgn="t">
+                        <a:buNone/>
+                      </a:pPr>
+                      <a:r>
+                        <a:rPr lang="zh-CN" sz="1600" u="none" strike="noStrike">
+                          <a:effectLst/>
+                        </a:rPr>
+                        <a:t>旁白</a:t>
+                      </a:r>
+                      <a:endParaRPr lang="zh-CN" sz="1600" b="0" i="0" u="none" strike="noStrike">
+                        <a:solidFill>
+                          <a:srgbClr val="000000"/>
+                        </a:solidFill>
+                        <a:effectLst/>
+                        <a:latin typeface="等线" panose="02010600030101010101" pitchFamily="2" charset="-122"/>
+                        <a:ea typeface="等线" panose="02010600030101010101" pitchFamily="2" charset="-122"/>
+                      </a:endParaRPr>
+                    </a:p>
+                  </a:txBody>
+                  <a:tcPr marL="6350" marR="6350" marT="6350" marB="0"/>
+                </a:tc>
+                <a:extLst>
+                  <a:ext uri="{0D108BD9-81ED-4DB2-BD59-A6C34878D82A}">
+                    <a16:rowId xmlns:a16="http://schemas.microsoft.com/office/drawing/2014/main" val="1806158059"/>
+                  </a:ext>
+                </a:extLst>
+              </a:tr>
+              <a:tr h="357760">
+                <a:tc>
+                  <a:txBody>
+                    <a:bodyPr/>
+                    <a:lstStyle/>
+                    <a:p>
+                      <a:pPr algn="ctr" fontAlgn="t">
+                        <a:buNone/>
+                      </a:pPr>
+                      <a:r>
+                        <a:rPr lang="zh-CN" sz="1600" u="none" strike="noStrike">
+                          <a:effectLst/>
+                        </a:rPr>
+                        <a:t>赵梓昊</a:t>
+                      </a:r>
+                      <a:endParaRPr lang="zh-CN" sz="1600" b="0" i="0" u="none" strike="noStrike">
+                        <a:solidFill>
+                          <a:srgbClr val="000000"/>
+                        </a:solidFill>
+                        <a:effectLst/>
+                        <a:latin typeface="等线" panose="02010600030101010101" pitchFamily="2" charset="-122"/>
+                        <a:ea typeface="等线" panose="02010600030101010101" pitchFamily="2" charset="-122"/>
+                      </a:endParaRPr>
+                    </a:p>
+                  </a:txBody>
+                  <a:tcPr marL="6350" marR="6350" marT="6350" marB="0"/>
+                </a:tc>
+                <a:tc>
+                  <a:txBody>
+                    <a:bodyPr/>
+                    <a:lstStyle/>
+                    <a:p>
+                      <a:pPr algn="ctr" fontAlgn="t">
+                        <a:buNone/>
+                      </a:pPr>
+                      <a:r>
+                        <a:rPr lang="zh-CN" sz="1600" u="none" strike="noStrike">
+                          <a:effectLst/>
+                        </a:rPr>
+                        <a:t>演员</a:t>
+                      </a:r>
+                      <a:endParaRPr lang="zh-CN" sz="1600" b="0" i="0" u="none" strike="noStrike">
+                        <a:solidFill>
+                          <a:srgbClr val="000000"/>
+                        </a:solidFill>
+                        <a:effectLst/>
+                        <a:latin typeface="等线" panose="02010600030101010101" pitchFamily="2" charset="-122"/>
+                        <a:ea typeface="等线" panose="02010600030101010101" pitchFamily="2" charset="-122"/>
+                      </a:endParaRPr>
+                    </a:p>
+                  </a:txBody>
+                  <a:tcPr marL="6350" marR="6350" marT="6350" marB="0"/>
+                </a:tc>
+                <a:extLst>
+                  <a:ext uri="{0D108BD9-81ED-4DB2-BD59-A6C34878D82A}">
+                    <a16:rowId xmlns:a16="http://schemas.microsoft.com/office/drawing/2014/main" val="1428140260"/>
+                  </a:ext>
+                </a:extLst>
+              </a:tr>
+              <a:tr h="357760">
+                <a:tc>
+                  <a:txBody>
+                    <a:bodyPr/>
+                    <a:lstStyle/>
+                    <a:p>
+                      <a:pPr algn="ctr" fontAlgn="t">
+                        <a:buNone/>
+                      </a:pPr>
+                      <a:r>
+                        <a:rPr lang="zh-CN" sz="1600" u="none" strike="noStrike">
+                          <a:effectLst/>
+                        </a:rPr>
+                        <a:t>王博然</a:t>
+                      </a:r>
+                      <a:endParaRPr lang="zh-CN" sz="1600" b="0" i="0" u="none" strike="noStrike">
+                        <a:solidFill>
+                          <a:srgbClr val="000000"/>
+                        </a:solidFill>
+                        <a:effectLst/>
+                        <a:latin typeface="等线" panose="02010600030101010101" pitchFamily="2" charset="-122"/>
+                        <a:ea typeface="等线" panose="02010600030101010101" pitchFamily="2" charset="-122"/>
+                      </a:endParaRPr>
+                    </a:p>
+                  </a:txBody>
+                  <a:tcPr marL="6350" marR="6350" marT="6350" marB="0"/>
+                </a:tc>
+                <a:tc>
+                  <a:txBody>
+                    <a:bodyPr/>
+                    <a:lstStyle/>
+                    <a:p>
+                      <a:pPr algn="ctr" fontAlgn="t">
+                        <a:buNone/>
+                      </a:pPr>
+                      <a:r>
+                        <a:rPr lang="zh-CN" sz="1600" u="none" strike="noStrike">
+                          <a:effectLst/>
+                        </a:rPr>
+                        <a:t>演员</a:t>
+                      </a:r>
+                      <a:endParaRPr lang="zh-CN" sz="1600" b="0" i="0" u="none" strike="noStrike">
+                        <a:solidFill>
+                          <a:srgbClr val="000000"/>
+                        </a:solidFill>
+                        <a:effectLst/>
+                        <a:latin typeface="等线" panose="02010600030101010101" pitchFamily="2" charset="-122"/>
+                        <a:ea typeface="等线" panose="02010600030101010101" pitchFamily="2" charset="-122"/>
+                      </a:endParaRPr>
+                    </a:p>
+                  </a:txBody>
+                  <a:tcPr marL="6350" marR="6350" marT="6350" marB="0"/>
+                </a:tc>
+                <a:extLst>
+                  <a:ext uri="{0D108BD9-81ED-4DB2-BD59-A6C34878D82A}">
+                    <a16:rowId xmlns:a16="http://schemas.microsoft.com/office/drawing/2014/main" val="1590098318"/>
+                  </a:ext>
+                </a:extLst>
+              </a:tr>
+              <a:tr h="357760">
+                <a:tc>
+                  <a:txBody>
+                    <a:bodyPr/>
+                    <a:lstStyle/>
+                    <a:p>
+                      <a:pPr algn="ctr" fontAlgn="t">
+                        <a:buNone/>
+                      </a:pPr>
+                      <a:r>
+                        <a:rPr lang="zh-CN" sz="1600" u="none" strike="noStrike">
+                          <a:effectLst/>
+                        </a:rPr>
+                        <a:t>张贺衍</a:t>
+                      </a:r>
+                      <a:endParaRPr lang="zh-CN" sz="1600" b="0" i="0" u="none" strike="noStrike">
+                        <a:solidFill>
+                          <a:srgbClr val="000000"/>
+                        </a:solidFill>
+                        <a:effectLst/>
+                        <a:latin typeface="等线" panose="02010600030101010101" pitchFamily="2" charset="-122"/>
+                        <a:ea typeface="等线" panose="02010600030101010101" pitchFamily="2" charset="-122"/>
+                      </a:endParaRPr>
+                    </a:p>
+                  </a:txBody>
+                  <a:tcPr marL="6350" marR="6350" marT="6350" marB="0"/>
+                </a:tc>
+                <a:tc>
+                  <a:txBody>
+                    <a:bodyPr/>
+                    <a:lstStyle/>
+                    <a:p>
+                      <a:pPr algn="ctr" fontAlgn="t">
+                        <a:buNone/>
+                      </a:pPr>
+                      <a:r>
+                        <a:rPr lang="zh-CN" sz="1600" u="none" strike="noStrike">
+                          <a:effectLst/>
+                        </a:rPr>
+                        <a:t>ppt制作（3，4，5 页），演员</a:t>
+                      </a:r>
+                      <a:endParaRPr lang="zh-CN" sz="1600" b="0" i="0" u="none" strike="noStrike">
+                        <a:solidFill>
+                          <a:srgbClr val="000000"/>
+                        </a:solidFill>
+                        <a:effectLst/>
+                        <a:latin typeface="等线" panose="02010600030101010101" pitchFamily="2" charset="-122"/>
+                        <a:ea typeface="等线" panose="02010600030101010101" pitchFamily="2" charset="-122"/>
+                      </a:endParaRPr>
+                    </a:p>
+                  </a:txBody>
+                  <a:tcPr marL="6350" marR="6350" marT="6350" marB="0"/>
+                </a:tc>
+                <a:extLst>
+                  <a:ext uri="{0D108BD9-81ED-4DB2-BD59-A6C34878D82A}">
+                    <a16:rowId xmlns:a16="http://schemas.microsoft.com/office/drawing/2014/main" val="1054622054"/>
+                  </a:ext>
+                </a:extLst>
+              </a:tr>
+              <a:tr h="357760">
+                <a:tc>
+                  <a:txBody>
+                    <a:bodyPr/>
+                    <a:lstStyle/>
+                    <a:p>
+                      <a:pPr algn="ctr" fontAlgn="t">
+                        <a:buNone/>
+                      </a:pPr>
+                      <a:r>
+                        <a:rPr lang="zh-CN" sz="1600" u="none" strike="noStrike">
+                          <a:effectLst/>
+                        </a:rPr>
+                        <a:t>郭柄君</a:t>
+                      </a:r>
+                      <a:endParaRPr lang="zh-CN" sz="1600" b="0" i="0" u="none" strike="noStrike">
+                        <a:solidFill>
+                          <a:srgbClr val="000000"/>
+                        </a:solidFill>
+                        <a:effectLst/>
+                        <a:latin typeface="等线" panose="02010600030101010101" pitchFamily="2" charset="-122"/>
+                        <a:ea typeface="等线" panose="02010600030101010101" pitchFamily="2" charset="-122"/>
+                      </a:endParaRPr>
+                    </a:p>
+                  </a:txBody>
+                  <a:tcPr marL="6350" marR="6350" marT="6350" marB="0"/>
+                </a:tc>
+                <a:tc>
+                  <a:txBody>
+                    <a:bodyPr/>
+                    <a:lstStyle/>
+                    <a:p>
+                      <a:pPr algn="ctr" fontAlgn="t">
+                        <a:buNone/>
+                      </a:pPr>
+                      <a:r>
+                        <a:rPr lang="zh-CN" sz="1600" u="none" strike="noStrike">
+                          <a:effectLst/>
+                        </a:rPr>
+                        <a:t>演员</a:t>
+                      </a:r>
+                      <a:endParaRPr lang="zh-CN" sz="1600" b="0" i="0" u="none" strike="noStrike">
+                        <a:solidFill>
+                          <a:srgbClr val="000000"/>
+                        </a:solidFill>
+                        <a:effectLst/>
+                        <a:latin typeface="等线" panose="02010600030101010101" pitchFamily="2" charset="-122"/>
+                        <a:ea typeface="等线" panose="02010600030101010101" pitchFamily="2" charset="-122"/>
+                      </a:endParaRPr>
+                    </a:p>
+                  </a:txBody>
+                  <a:tcPr marL="6350" marR="6350" marT="6350" marB="0"/>
+                </a:tc>
+                <a:extLst>
+                  <a:ext uri="{0D108BD9-81ED-4DB2-BD59-A6C34878D82A}">
+                    <a16:rowId xmlns:a16="http://schemas.microsoft.com/office/drawing/2014/main" val="2961987211"/>
+                  </a:ext>
+                </a:extLst>
+              </a:tr>
+              <a:tr h="556674">
+                <a:tc>
+                  <a:txBody>
+                    <a:bodyPr/>
+                    <a:lstStyle/>
+                    <a:p>
+                      <a:pPr algn="ctr" fontAlgn="t">
+                        <a:buNone/>
+                      </a:pPr>
+                      <a:r>
+                        <a:rPr lang="zh-CN" sz="1600" u="none" strike="noStrike">
+                          <a:effectLst/>
+                        </a:rPr>
+                        <a:t>刘安泽</a:t>
+                      </a:r>
+                      <a:endParaRPr lang="zh-CN" sz="1600" b="0" i="0" u="none" strike="noStrike">
+                        <a:solidFill>
+                          <a:srgbClr val="000000"/>
+                        </a:solidFill>
+                        <a:effectLst/>
+                        <a:latin typeface="等线" panose="02010600030101010101" pitchFamily="2" charset="-122"/>
+                        <a:ea typeface="等线" panose="02010600030101010101" pitchFamily="2" charset="-122"/>
+                      </a:endParaRPr>
+                    </a:p>
+                  </a:txBody>
+                  <a:tcPr marL="6350" marR="6350" marT="6350" marB="0"/>
+                </a:tc>
+                <a:tc>
+                  <a:txBody>
+                    <a:bodyPr/>
+                    <a:lstStyle/>
+                    <a:p>
+                      <a:pPr algn="ctr" fontAlgn="t">
+                        <a:buNone/>
+                      </a:pPr>
+                      <a:r>
+                        <a:rPr lang="zh-CN" sz="1600" u="none" strike="noStrike">
+                          <a:effectLst/>
+                        </a:rPr>
+                        <a:t>ppt制作（1，2，6 页），ppt播放</a:t>
+                      </a:r>
+                      <a:endParaRPr lang="zh-CN" sz="1600" b="0" i="0" u="none" strike="noStrike">
+                        <a:solidFill>
+                          <a:srgbClr val="000000"/>
+                        </a:solidFill>
+                        <a:effectLst/>
+                        <a:latin typeface="等线" panose="02010600030101010101" pitchFamily="2" charset="-122"/>
+                        <a:ea typeface="等线" panose="02010600030101010101" pitchFamily="2" charset="-122"/>
+                      </a:endParaRPr>
+                    </a:p>
+                  </a:txBody>
+                  <a:tcPr marL="6350" marR="6350" marT="6350" marB="0"/>
+                </a:tc>
+                <a:extLst>
+                  <a:ext uri="{0D108BD9-81ED-4DB2-BD59-A6C34878D82A}">
+                    <a16:rowId xmlns:a16="http://schemas.microsoft.com/office/drawing/2014/main" val="3588945687"/>
+                  </a:ext>
+                </a:extLst>
+              </a:tr>
+              <a:tr h="357760">
+                <a:tc>
+                  <a:txBody>
+                    <a:bodyPr/>
+                    <a:lstStyle/>
+                    <a:p>
+                      <a:pPr algn="ctr" fontAlgn="t">
+                        <a:buNone/>
+                      </a:pPr>
+                      <a:r>
+                        <a:rPr lang="zh-CN" sz="1600" u="none" strike="noStrike">
+                          <a:effectLst/>
+                        </a:rPr>
+                        <a:t>姜昱言</a:t>
+                      </a:r>
+                      <a:endParaRPr lang="zh-CN" sz="1600" b="0" i="0" u="none" strike="noStrike">
+                        <a:solidFill>
+                          <a:srgbClr val="000000"/>
+                        </a:solidFill>
+                        <a:effectLst/>
+                        <a:latin typeface="等线" panose="02010600030101010101" pitchFamily="2" charset="-122"/>
+                        <a:ea typeface="等线" panose="02010600030101010101" pitchFamily="2" charset="-122"/>
+                      </a:endParaRPr>
+                    </a:p>
+                  </a:txBody>
+                  <a:tcPr marL="6350" marR="6350" marT="6350" marB="0"/>
+                </a:tc>
+                <a:tc>
+                  <a:txBody>
+                    <a:bodyPr/>
+                    <a:lstStyle/>
+                    <a:p>
+                      <a:pPr algn="ctr" fontAlgn="t">
+                        <a:buNone/>
+                      </a:pPr>
+                      <a:r>
+                        <a:rPr lang="zh-CN" sz="1600" u="none" strike="noStrike" dirty="0">
+                          <a:effectLst/>
+                        </a:rPr>
+                        <a:t>文稿书写</a:t>
+                      </a:r>
+                      <a:endParaRPr lang="zh-CN" sz="1600" b="0" i="0" u="none" strike="noStrike" dirty="0">
+                        <a:solidFill>
+                          <a:srgbClr val="000000"/>
+                        </a:solidFill>
+                        <a:effectLst/>
+                        <a:latin typeface="等线" panose="02010600030101010101" pitchFamily="2" charset="-122"/>
+                        <a:ea typeface="等线" panose="02010600030101010101" pitchFamily="2" charset="-122"/>
+                      </a:endParaRPr>
+                    </a:p>
+                  </a:txBody>
+                  <a:tcPr marL="6350" marR="6350" marT="6350" marB="0"/>
+                </a:tc>
+                <a:extLst>
+                  <a:ext uri="{0D108BD9-81ED-4DB2-BD59-A6C34878D82A}">
+                    <a16:rowId xmlns:a16="http://schemas.microsoft.com/office/drawing/2014/main" val="524005334"/>
+                  </a:ext>
+                </a:extLst>
+              </a:tr>
+            </a:tbl>
+          </a:graphicData>
+        </a:graphic>
+      </p:graphicFrame>
     </p:spTree>
     <p:extLst>
       <p:ext uri="{BB962C8B-B14F-4D97-AF65-F5344CB8AC3E}">
-        <p14:creationId xmlns:p14="http://schemas.microsoft.com/office/powerpoint/2010/main" val="3911739994"/>
+        <p14:creationId xmlns:p14="http://schemas.microsoft.com/office/powerpoint/2010/main" val="2242557045"/>
       </p:ext>
     </p:extLst>
   </p:cSld>
   <p:clrMapOvr>
     <a:masterClrMapping/>
   </p:clrMapOvr>
-  <mc:AlternateContent xmlns:mc="http://schemas.openxmlformats.org/markup-compatibility/2006">
-    <mc:Choice xmlns:p14="http://schemas.microsoft.com/office/powerpoint/2010/main" Requires="p14">
-      <p:transition spd="slow" p14:dur="2500">
-        <p14:vortex dir="r"/>
-      </p:transition>
-    </mc:Choice>
-    <mc:Fallback>
-      <p:transition spd="slow">
-        <p:fade/>
-      </p:transition>
-    </mc:Fallback>
-  </mc:AlternateContent>
   <p:timing>
     <p:tnLst>
       <p:par>
@@ -10509,6 +10009,9 @@
                     <p:cTn id="3" fill="hold">
                       <p:stCondLst>
                         <p:cond delay="indefinite"/>
+                        <p:cond evt="onBegin" delay="0">
+                          <p:tn val="2"/>
+                        </p:cond>
                       </p:stCondLst>
                       <p:childTnLst>
                         <p:par>
@@ -10518,7 +10021,7 @@
                             </p:stCondLst>
                             <p:childTnLst>
                               <p:par>
-                                <p:cTn id="5" presetID="1" presetClass="entr" presetSubtype="0" fill="hold" nodeType="clickEffect">
+                                <p:cTn id="5" presetID="1" presetClass="entr" presetSubtype="0" fill="hold" nodeType="withEffect">
                                   <p:stCondLst>
                                     <p:cond delay="0"/>
                                   </p:stCondLst>
@@ -10531,244 +10034,7 @@
                                           </p:stCondLst>
                                         </p:cTn>
                                         <p:tgtEl>
-                                          <p:spTgt spid="8"/>
-                                        </p:tgtEl>
-                                        <p:attrNameLst>
-                                          <p:attrName>style.visibility</p:attrName>
-                                        </p:attrNameLst>
-                                      </p:cBhvr>
-                                      <p:to>
-                                        <p:strVal val="visible"/>
-                                      </p:to>
-                                    </p:set>
-                                  </p:childTnLst>
-                                </p:cTn>
-                              </p:par>
-                              <p:par>
-                                <p:cTn id="7" presetID="1" presetClass="entr" presetSubtype="0" fill="hold" grpId="0" nodeType="withEffect">
-                                  <p:stCondLst>
-                                    <p:cond delay="0"/>
-                                  </p:stCondLst>
-                                  <p:childTnLst>
-                                    <p:set>
-                                      <p:cBhvr>
-                                        <p:cTn id="8" dur="1" fill="hold">
-                                          <p:stCondLst>
-                                            <p:cond delay="0"/>
-                                          </p:stCondLst>
-                                        </p:cTn>
-                                        <p:tgtEl>
-                                          <p:spTgt spid="5">
-                                            <p:txEl>
-                                              <p:pRg st="0" end="0"/>
-                                            </p:txEl>
-                                          </p:spTgt>
-                                        </p:tgtEl>
-                                        <p:attrNameLst>
-                                          <p:attrName>style.visibility</p:attrName>
-                                        </p:attrNameLst>
-                                      </p:cBhvr>
-                                      <p:to>
-                                        <p:strVal val="visible"/>
-                                      </p:to>
-                                    </p:set>
-                                  </p:childTnLst>
-                                </p:cTn>
-                              </p:par>
-                            </p:childTnLst>
-                          </p:cTn>
-                        </p:par>
-                      </p:childTnLst>
-                    </p:cTn>
-                  </p:par>
-                  <p:par>
-                    <p:cTn id="9" fill="hold">
-                      <p:stCondLst>
-                        <p:cond delay="indefinite"/>
-                      </p:stCondLst>
-                      <p:childTnLst>
-                        <p:par>
-                          <p:cTn id="10" fill="hold">
-                            <p:stCondLst>
-                              <p:cond delay="0"/>
-                            </p:stCondLst>
-                            <p:childTnLst>
-                              <p:par>
-                                <p:cTn id="11" presetID="1" presetClass="exit" presetSubtype="0" fill="hold" nodeType="clickEffect">
-                                  <p:stCondLst>
-                                    <p:cond delay="0"/>
-                                  </p:stCondLst>
-                                  <p:childTnLst>
-                                    <p:set>
-                                      <p:cBhvr>
-                                        <p:cTn id="12" dur="1" fill="hold">
-                                          <p:stCondLst>
-                                            <p:cond delay="0"/>
-                                          </p:stCondLst>
-                                        </p:cTn>
-                                        <p:tgtEl>
-                                          <p:spTgt spid="8"/>
-                                        </p:tgtEl>
-                                        <p:attrNameLst>
-                                          <p:attrName>style.visibility</p:attrName>
-                                        </p:attrNameLst>
-                                      </p:cBhvr>
-                                      <p:to>
-                                        <p:strVal val="hidden"/>
-                                      </p:to>
-                                    </p:set>
-                                  </p:childTnLst>
-                                </p:cTn>
-                              </p:par>
-                              <p:par>
-                                <p:cTn id="13" presetID="1" presetClass="exit" presetSubtype="0" fill="hold" grpId="1" nodeType="withEffect">
-                                  <p:stCondLst>
-                                    <p:cond delay="0"/>
-                                  </p:stCondLst>
-                                  <p:childTnLst>
-                                    <p:set>
-                                      <p:cBhvr>
-                                        <p:cTn id="14" dur="1" fill="hold">
-                                          <p:stCondLst>
-                                            <p:cond delay="0"/>
-                                          </p:stCondLst>
-                                        </p:cTn>
-                                        <p:tgtEl>
-                                          <p:spTgt spid="5">
-                                            <p:txEl>
-                                              <p:pRg st="0" end="0"/>
-                                            </p:txEl>
-                                          </p:spTgt>
-                                        </p:tgtEl>
-                                        <p:attrNameLst>
-                                          <p:attrName>style.visibility</p:attrName>
-                                        </p:attrNameLst>
-                                      </p:cBhvr>
-                                      <p:to>
-                                        <p:strVal val="hidden"/>
-                                      </p:to>
-                                    </p:set>
-                                  </p:childTnLst>
-                                </p:cTn>
-                              </p:par>
-                            </p:childTnLst>
-                          </p:cTn>
-                        </p:par>
-                      </p:childTnLst>
-                    </p:cTn>
-                  </p:par>
-                  <p:par>
-                    <p:cTn id="15" fill="hold">
-                      <p:stCondLst>
-                        <p:cond delay="indefinite"/>
-                      </p:stCondLst>
-                      <p:childTnLst>
-                        <p:par>
-                          <p:cTn id="16" fill="hold">
-                            <p:stCondLst>
-                              <p:cond delay="0"/>
-                            </p:stCondLst>
-                            <p:childTnLst>
-                              <p:par>
-                                <p:cTn id="17" presetID="1" presetClass="entr" presetSubtype="0" fill="hold" grpId="0" nodeType="clickEffect">
-                                  <p:stCondLst>
-                                    <p:cond delay="0"/>
-                                  </p:stCondLst>
-                                  <p:childTnLst>
-                                    <p:set>
-                                      <p:cBhvr>
-                                        <p:cTn id="18" dur="1" fill="hold">
-                                          <p:stCondLst>
-                                            <p:cond delay="0"/>
-                                          </p:stCondLst>
-                                        </p:cTn>
-                                        <p:tgtEl>
-                                          <p:spTgt spid="6">
-                                            <p:txEl>
-                                              <p:pRg st="0" end="0"/>
-                                            </p:txEl>
-                                          </p:spTgt>
-                                        </p:tgtEl>
-                                        <p:attrNameLst>
-                                          <p:attrName>style.visibility</p:attrName>
-                                        </p:attrNameLst>
-                                      </p:cBhvr>
-                                      <p:to>
-                                        <p:strVal val="visible"/>
-                                      </p:to>
-                                    </p:set>
-                                  </p:childTnLst>
-                                </p:cTn>
-                              </p:par>
-                              <p:par>
-                                <p:cTn id="19" presetID="1" presetClass="entr" presetSubtype="0" fill="hold" nodeType="withEffect">
-                                  <p:stCondLst>
-                                    <p:cond delay="0"/>
-                                  </p:stCondLst>
-                                  <p:childTnLst>
-                                    <p:set>
-                                      <p:cBhvr>
-                                        <p:cTn id="20" dur="1" fill="hold">
-                                          <p:stCondLst>
-                                            <p:cond delay="0"/>
-                                          </p:stCondLst>
-                                        </p:cTn>
-                                        <p:tgtEl>
-                                          <p:spTgt spid="10"/>
-                                        </p:tgtEl>
-                                        <p:attrNameLst>
-                                          <p:attrName>style.visibility</p:attrName>
-                                        </p:attrNameLst>
-                                      </p:cBhvr>
-                                      <p:to>
-                                        <p:strVal val="visible"/>
-                                      </p:to>
-                                    </p:set>
-                                  </p:childTnLst>
-                                </p:cTn>
-                              </p:par>
-                              <p:par>
-                                <p:cTn id="21" presetID="1" presetClass="entr" presetSubtype="0" fill="hold" nodeType="withEffect">
-                                  <p:stCondLst>
-                                    <p:cond delay="0"/>
-                                  </p:stCondLst>
-                                  <p:childTnLst>
-                                    <p:set>
-                                      <p:cBhvr>
-                                        <p:cTn id="22" dur="1" fill="hold">
-                                          <p:stCondLst>
-                                            <p:cond delay="0"/>
-                                          </p:stCondLst>
-                                        </p:cTn>
-                                        <p:tgtEl>
                                           <p:spTgt spid="12"/>
-                                        </p:tgtEl>
-                                        <p:attrNameLst>
-                                          <p:attrName>style.visibility</p:attrName>
-                                        </p:attrNameLst>
-                                      </p:cBhvr>
-                                      <p:to>
-                                        <p:strVal val="visible"/>
-                                      </p:to>
-                                    </p:set>
-                                  </p:childTnLst>
-                                </p:cTn>
-                              </p:par>
-                              <p:par>
-                                <p:cTn id="23" presetID="1" presetClass="entr" presetSubtype="0" fill="hold" nodeType="withEffect">
-                                  <p:stCondLst>
-                                    <p:cond delay="0"/>
-                                  </p:stCondLst>
-                                  <p:childTnLst>
-                                    <p:set>
-                                      <p:cBhvr>
-                                        <p:cTn id="24" dur="1" fill="hold">
-                                          <p:stCondLst>
-                                            <p:cond delay="0"/>
-                                          </p:stCondLst>
-                                        </p:cTn>
-                                        <p:tgtEl>
-                                          <p:spTgt spid="14"/>
                                         </p:tgtEl>
                                         <p:attrNameLst>
                                           <p:attrName>style.visibility</p:attrName>
@@ -10808,11 +10074,6 @@
         </p:cTn>
       </p:par>
     </p:tnLst>
-    <p:bldLst>
-      <p:bldP spid="5" grpId="0" build="p"/>
-      <p:bldP spid="5" grpId="1" build="p"/>
-      <p:bldP spid="6" grpId="0" build="p"/>
-    </p:bldLst>
   </p:timing>
 </p:sld>
 </file>

</xml_diff>

<commit_message>
modified:   README.md 	modified:   "\343\200\212\345\215\203\345\271\264\345\234\237\345\234\260\347\277\273\344\272\206\350\272\253\343\200\213.pptx" 	modified:   "\347\273\204\345\206\205\346\210\220\345\221\230\350\241\250.xlsx"
</commit_message>
<xml_diff>
--- a/《千年土地翻了身》.pptx
+++ b/《千年土地翻了身》.pptx
@@ -8945,8 +8945,8 @@
         </p:nvSpPr>
         <p:spPr>
           <a:xfrm>
-            <a:off x="583008" y="3768064"/>
-            <a:ext cx="10463436" cy="2308324"/>
+            <a:off x="1580719" y="3860231"/>
+            <a:ext cx="10315908" cy="2677656"/>
           </a:xfrm>
           <a:prstGeom prst="rect">
             <a:avLst/>
@@ -8960,19 +8960,28 @@
           <a:lstStyle/>
           <a:p>
             <a:r>
-              <a:rPr lang="zh-CN" altLang="zh-CN" sz="2400" dirty="0"/>
+              <a:rPr lang="zh-CN" altLang="zh-CN" sz="2800" dirty="0">
+                <a:latin typeface="楷体" panose="02010609060101010101" pitchFamily="49" charset="-122"/>
+                <a:ea typeface="楷体" panose="02010609060101010101" pitchFamily="49" charset="-122"/>
+              </a:rPr>
               <a:t>这幅画代表新中国美术发展。董希文三进西藏写生，积累素材。他以朴素画风表现西藏农奴翻身做主，在土地上耕耘的喜悦。</a:t>
             </a:r>
           </a:p>
           <a:p>
             <a:r>
-              <a:rPr lang="zh-CN" altLang="zh-CN" sz="2400" dirty="0"/>
+              <a:rPr lang="zh-CN" altLang="zh-CN" sz="2800" dirty="0">
+                <a:latin typeface="楷体" panose="02010609060101010101" pitchFamily="49" charset="-122"/>
+                <a:ea typeface="楷体" panose="02010609060101010101" pitchFamily="49" charset="-122"/>
+              </a:rPr>
               <a:t>画面充满动感。人物后仰，牦牛奋蹄，笔触方向一致。雪山蓝天带来不一样的春天。</a:t>
             </a:r>
           </a:p>
           <a:p>
             <a:r>
-              <a:rPr lang="zh-CN" altLang="zh-CN" sz="2400" dirty="0"/>
+              <a:rPr lang="zh-CN" altLang="zh-CN" sz="2800" dirty="0">
+                <a:latin typeface="楷体" panose="02010609060101010101" pitchFamily="49" charset="-122"/>
+                <a:ea typeface="楷体" panose="02010609060101010101" pitchFamily="49" charset="-122"/>
+              </a:rPr>
               <a:t>对角线构图和桃红上衣与左下阴影对比。这表现出高原阳光，也表现出人物内心的激动喜悦。</a:t>
             </a:r>
           </a:p>
@@ -8992,8 +9001,8 @@
         </p:nvSpPr>
         <p:spPr>
           <a:xfrm>
-            <a:off x="441859" y="997393"/>
-            <a:ext cx="5512992" cy="2123658"/>
+            <a:off x="235670" y="997393"/>
+            <a:ext cx="5719181" cy="2246769"/>
           </a:xfrm>
           <a:prstGeom prst="rect">
             <a:avLst/>
@@ -9007,18 +9016,30 @@
           <a:lstStyle/>
           <a:p>
             <a:r>
-              <a:rPr lang="en-US" altLang="zh-CN" sz="3600" dirty="0"/>
+              <a:rPr lang="en-US" altLang="zh-CN" sz="3600" dirty="0">
+                <a:latin typeface="楷体" panose="02010609060101010101" pitchFamily="49" charset="-122"/>
+                <a:ea typeface="楷体" panose="02010609060101010101" pitchFamily="49" charset="-122"/>
+              </a:rPr>
               <a:t>《</a:t>
             </a:r>
             <a:r>
-              <a:rPr lang="zh-CN" altLang="zh-CN" sz="3600" dirty="0"/>
+              <a:rPr lang="zh-CN" altLang="zh-CN" sz="3600" dirty="0">
+                <a:latin typeface="楷体" panose="02010609060101010101" pitchFamily="49" charset="-122"/>
+                <a:ea typeface="楷体" panose="02010609060101010101" pitchFamily="49" charset="-122"/>
+              </a:rPr>
               <a:t>千年土地翻了身》</a:t>
             </a:r>
-            <a:endParaRPr lang="en-US" altLang="zh-CN" sz="3600" dirty="0"/>
-          </a:p>
-          <a:p>
-            <a:r>
-              <a:rPr lang="zh-CN" altLang="zh-CN" sz="3200" dirty="0"/>
+            <a:endParaRPr lang="en-US" altLang="zh-CN" sz="3600" dirty="0">
+              <a:latin typeface="楷体" panose="02010609060101010101" pitchFamily="49" charset="-122"/>
+              <a:ea typeface="楷体" panose="02010609060101010101" pitchFamily="49" charset="-122"/>
+            </a:endParaRPr>
+          </a:p>
+          <a:p>
+            <a:r>
+              <a:rPr lang="zh-CN" altLang="zh-CN" sz="3600" dirty="0">
+                <a:latin typeface="楷体" panose="02010609060101010101" pitchFamily="49" charset="-122"/>
+                <a:ea typeface="楷体" panose="02010609060101010101" pitchFamily="49" charset="-122"/>
+              </a:rPr>
               <a:t>是董希文1963年油画，藏中国美术馆。</a:t>
             </a:r>
           </a:p>
@@ -9143,7 +9164,7 @@
         </p:nvSpPr>
         <p:spPr>
           <a:xfrm>
-            <a:off x="707009" y="3784861"/>
+            <a:off x="510618" y="3784861"/>
             <a:ext cx="11170763" cy="2832756"/>
           </a:xfrm>
         </p:spPr>
@@ -9154,178 +9175,277 @@
           <a:lstStyle/>
           <a:p>
             <a:r>
-              <a:rPr lang="zh-CN" altLang="zh-CN" sz="3200" dirty="0"/>
+              <a:rPr lang="zh-CN" altLang="zh-CN" sz="3100" dirty="0">
+                <a:latin typeface="楷体" panose="02010609060101010101" pitchFamily="49" charset="-122"/>
+                <a:ea typeface="楷体" panose="02010609060101010101" pitchFamily="49" charset="-122"/>
+              </a:rPr>
               <a:t>1.感谢</a:t>
             </a:r>
             <a:r>
-              <a:rPr lang="zh-CN" altLang="zh-CN" sz="3200" dirty="0">
+              <a:rPr lang="zh-CN" altLang="zh-CN" sz="3100" dirty="0">
                 <a:highlight>
                   <a:srgbClr val="00FFFF"/>
                 </a:highlight>
+                <a:latin typeface="楷体" panose="02010609060101010101" pitchFamily="49" charset="-122"/>
+                <a:ea typeface="楷体" panose="02010609060101010101" pitchFamily="49" charset="-122"/>
               </a:rPr>
               <a:t>美术教材</a:t>
             </a:r>
             <a:r>
-              <a:rPr lang="zh-CN" altLang="zh-CN" sz="3200" dirty="0"/>
+              <a:rPr lang="zh-CN" altLang="zh-CN" sz="3100" dirty="0">
+                <a:latin typeface="楷体" panose="02010609060101010101" pitchFamily="49" charset="-122"/>
+                <a:ea typeface="楷体" panose="02010609060101010101" pitchFamily="49" charset="-122"/>
+              </a:rPr>
               <a:t>催生了这个</a:t>
             </a:r>
             <a:r>
-              <a:rPr lang="zh-CN" altLang="zh-CN" sz="3200" dirty="0">
+              <a:rPr lang="zh-CN" altLang="zh-CN" sz="3100" dirty="0">
                 <a:highlight>
                   <a:srgbClr val="00FFFF"/>
                 </a:highlight>
+                <a:latin typeface="楷体" panose="02010609060101010101" pitchFamily="49" charset="-122"/>
+                <a:ea typeface="楷体" panose="02010609060101010101" pitchFamily="49" charset="-122"/>
               </a:rPr>
               <a:t>PPT</a:t>
             </a:r>
             <a:r>
-              <a:rPr lang="zh-CN" altLang="zh-CN" sz="3200" dirty="0"/>
+              <a:rPr lang="zh-CN" altLang="zh-CN" sz="3100" dirty="0">
+                <a:latin typeface="楷体" panose="02010609060101010101" pitchFamily="49" charset="-122"/>
+                <a:ea typeface="楷体" panose="02010609060101010101" pitchFamily="49" charset="-122"/>
+              </a:rPr>
               <a:t>。</a:t>
             </a:r>
             <a:br>
-              <a:rPr lang="en-US" altLang="zh-CN" sz="3200" dirty="0"/>
+              <a:rPr lang="en-US" altLang="zh-CN" sz="3100" dirty="0">
+                <a:latin typeface="楷体" panose="02010609060101010101" pitchFamily="49" charset="-122"/>
+                <a:ea typeface="楷体" panose="02010609060101010101" pitchFamily="49" charset="-122"/>
+              </a:rPr>
             </a:br>
             <a:r>
-              <a:rPr lang="en-US" altLang="zh-CN" sz="3200" dirty="0"/>
+              <a:rPr lang="en-US" altLang="zh-CN" sz="3100" dirty="0">
+                <a:latin typeface="楷体" panose="02010609060101010101" pitchFamily="49" charset="-122"/>
+                <a:ea typeface="楷体" panose="02010609060101010101" pitchFamily="49" charset="-122"/>
+              </a:rPr>
               <a:t>2.</a:t>
             </a:r>
             <a:r>
-              <a:rPr lang="zh-CN" altLang="zh-CN" sz="2800" dirty="0"/>
+              <a:rPr lang="zh-CN" altLang="zh-CN" sz="3100" dirty="0">
+                <a:latin typeface="楷体" panose="02010609060101010101" pitchFamily="49" charset="-122"/>
+                <a:ea typeface="楷体" panose="02010609060101010101" pitchFamily="49" charset="-122"/>
+              </a:rPr>
               <a:t>感谢</a:t>
             </a:r>
             <a:r>
-              <a:rPr lang="zh-CN" altLang="zh-CN" sz="2800" dirty="0">
+              <a:rPr lang="zh-CN" altLang="zh-CN" sz="3100" dirty="0">
                 <a:highlight>
                   <a:srgbClr val="00FFFF"/>
                 </a:highlight>
+                <a:latin typeface="楷体" panose="02010609060101010101" pitchFamily="49" charset="-122"/>
+                <a:ea typeface="楷体" panose="02010609060101010101" pitchFamily="49" charset="-122"/>
               </a:rPr>
               <a:t>deepseek</a:t>
             </a:r>
             <a:r>
-              <a:rPr lang="zh-CN" altLang="zh-CN" sz="2800" dirty="0"/>
+              <a:rPr lang="zh-CN" altLang="zh-CN" sz="3100" dirty="0">
+                <a:latin typeface="楷体" panose="02010609060101010101" pitchFamily="49" charset="-122"/>
+                <a:ea typeface="楷体" panose="02010609060101010101" pitchFamily="49" charset="-122"/>
+              </a:rPr>
               <a:t>提供了免费的文本编写服务。</a:t>
             </a:r>
             <a:br>
-              <a:rPr lang="zh-CN" altLang="zh-CN" sz="3200" dirty="0"/>
+              <a:rPr lang="zh-CN" altLang="zh-CN" sz="3100" dirty="0">
+                <a:latin typeface="楷体" panose="02010609060101010101" pitchFamily="49" charset="-122"/>
+                <a:ea typeface="楷体" panose="02010609060101010101" pitchFamily="49" charset="-122"/>
+              </a:rPr>
             </a:br>
             <a:r>
-              <a:rPr lang="en-US" altLang="zh-CN" sz="3200" dirty="0"/>
+              <a:rPr lang="en-US" altLang="zh-CN" sz="3100" dirty="0">
+                <a:latin typeface="楷体" panose="02010609060101010101" pitchFamily="49" charset="-122"/>
+                <a:ea typeface="楷体" panose="02010609060101010101" pitchFamily="49" charset="-122"/>
+              </a:rPr>
               <a:t>3</a:t>
             </a:r>
             <a:r>
-              <a:rPr lang="zh-CN" altLang="zh-CN" sz="3200" dirty="0"/>
+              <a:rPr lang="zh-CN" altLang="zh-CN" sz="3100" dirty="0">
+                <a:latin typeface="楷体" panose="02010609060101010101" pitchFamily="49" charset="-122"/>
+                <a:ea typeface="楷体" panose="02010609060101010101" pitchFamily="49" charset="-122"/>
+              </a:rPr>
               <a:t>.感谢</a:t>
             </a:r>
             <a:r>
-              <a:rPr lang="zh-CN" altLang="zh-CN" sz="3200" dirty="0">
+              <a:rPr lang="zh-CN" altLang="zh-CN" sz="3100" dirty="0">
                 <a:highlight>
                   <a:srgbClr val="00FFFF"/>
                 </a:highlight>
+                <a:latin typeface="楷体" panose="02010609060101010101" pitchFamily="49" charset="-122"/>
+                <a:ea typeface="楷体" panose="02010609060101010101" pitchFamily="49" charset="-122"/>
               </a:rPr>
               <a:t>千问</a:t>
             </a:r>
             <a:r>
-              <a:rPr lang="zh-CN" altLang="zh-CN" sz="3200" dirty="0"/>
+              <a:rPr lang="zh-CN" altLang="zh-CN" sz="3100" dirty="0">
+                <a:latin typeface="楷体" panose="02010609060101010101" pitchFamily="49" charset="-122"/>
+                <a:ea typeface="楷体" panose="02010609060101010101" pitchFamily="49" charset="-122"/>
+              </a:rPr>
               <a:t>提供了免费的 </a:t>
             </a:r>
             <a:r>
-              <a:rPr lang="zh-CN" altLang="zh-CN" sz="3200" dirty="0">
+              <a:rPr lang="zh-CN" altLang="zh-CN" sz="3100" dirty="0">
                 <a:highlight>
                   <a:srgbClr val="00FFFF"/>
                 </a:highlight>
+                <a:latin typeface="楷体" panose="02010609060101010101" pitchFamily="49" charset="-122"/>
+                <a:ea typeface="楷体" panose="02010609060101010101" pitchFamily="49" charset="-122"/>
               </a:rPr>
               <a:t>AI</a:t>
             </a:r>
             <a:r>
-              <a:rPr lang="zh-CN" altLang="zh-CN" sz="3200" dirty="0"/>
+              <a:rPr lang="zh-CN" altLang="zh-CN" sz="3100" dirty="0">
+                <a:latin typeface="楷体" panose="02010609060101010101" pitchFamily="49" charset="-122"/>
+                <a:ea typeface="楷体" panose="02010609060101010101" pitchFamily="49" charset="-122"/>
+              </a:rPr>
               <a:t> 图片清晰度提升服务。</a:t>
             </a:r>
             <a:br>
-              <a:rPr lang="zh-CN" altLang="zh-CN" sz="3200" dirty="0"/>
+              <a:rPr lang="zh-CN" altLang="zh-CN" sz="3100" dirty="0">
+                <a:latin typeface="楷体" panose="02010609060101010101" pitchFamily="49" charset="-122"/>
+                <a:ea typeface="楷体" panose="02010609060101010101" pitchFamily="49" charset="-122"/>
+              </a:rPr>
             </a:br>
             <a:r>
-              <a:rPr lang="en-US" altLang="zh-CN" sz="3200" dirty="0"/>
+              <a:rPr lang="en-US" altLang="zh-CN" sz="3100" dirty="0">
+                <a:latin typeface="楷体" panose="02010609060101010101" pitchFamily="49" charset="-122"/>
+                <a:ea typeface="楷体" panose="02010609060101010101" pitchFamily="49" charset="-122"/>
+              </a:rPr>
               <a:t>4.</a:t>
             </a:r>
             <a:r>
-              <a:rPr lang="zh-CN" altLang="zh-CN" dirty="0"/>
+              <a:rPr lang="zh-CN" altLang="zh-CN" sz="3100" dirty="0">
+                <a:latin typeface="楷体" panose="02010609060101010101" pitchFamily="49" charset="-122"/>
+                <a:ea typeface="楷体" panose="02010609060101010101" pitchFamily="49" charset="-122"/>
+              </a:rPr>
               <a:t>感谢</a:t>
             </a:r>
             <a:r>
-              <a:rPr lang="zh-CN" altLang="zh-CN" dirty="0">
+              <a:rPr lang="zh-CN" altLang="zh-CN" sz="3100" dirty="0">
                 <a:highlight>
                   <a:srgbClr val="00FFFF"/>
                 </a:highlight>
+                <a:latin typeface="楷体" panose="02010609060101010101" pitchFamily="49" charset="-122"/>
+                <a:ea typeface="楷体" panose="02010609060101010101" pitchFamily="49" charset="-122"/>
               </a:rPr>
               <a:t>中国美术馆网站</a:t>
             </a:r>
             <a:r>
-              <a:rPr lang="zh-CN" altLang="zh-CN" dirty="0"/>
+              <a:rPr lang="zh-CN" altLang="zh-CN" sz="3100" dirty="0">
+                <a:latin typeface="楷体" panose="02010609060101010101" pitchFamily="49" charset="-122"/>
+                <a:ea typeface="楷体" panose="02010609060101010101" pitchFamily="49" charset="-122"/>
+              </a:rPr>
               <a:t>提供了油画照片</a:t>
             </a:r>
             <a:br>
-              <a:rPr lang="en-US" altLang="zh-CN" sz="3200" dirty="0"/>
+              <a:rPr lang="en-US" altLang="zh-CN" sz="3100" dirty="0">
+                <a:latin typeface="楷体" panose="02010609060101010101" pitchFamily="49" charset="-122"/>
+                <a:ea typeface="楷体" panose="02010609060101010101" pitchFamily="49" charset="-122"/>
+              </a:rPr>
             </a:br>
             <a:r>
-              <a:rPr lang="en-US" altLang="zh-CN" sz="3200" dirty="0"/>
+              <a:rPr lang="en-US" altLang="zh-CN" sz="3100" dirty="0">
+                <a:latin typeface="楷体" panose="02010609060101010101" pitchFamily="49" charset="-122"/>
+                <a:ea typeface="楷体" panose="02010609060101010101" pitchFamily="49" charset="-122"/>
+              </a:rPr>
               <a:t>5</a:t>
             </a:r>
             <a:r>
-              <a:rPr lang="zh-CN" altLang="zh-CN" sz="3200" dirty="0"/>
+              <a:rPr lang="zh-CN" altLang="zh-CN" sz="3100" dirty="0">
+                <a:latin typeface="楷体" panose="02010609060101010101" pitchFamily="49" charset="-122"/>
+                <a:ea typeface="楷体" panose="02010609060101010101" pitchFamily="49" charset="-122"/>
+              </a:rPr>
               <a:t>.感谢我们的</a:t>
             </a:r>
             <a:r>
-              <a:rPr lang="zh-CN" altLang="zh-CN" sz="3200" dirty="0">
+              <a:rPr lang="zh-CN" altLang="zh-CN" sz="3100" dirty="0">
                 <a:highlight>
                   <a:srgbClr val="00FFFF"/>
                 </a:highlight>
+                <a:latin typeface="楷体" panose="02010609060101010101" pitchFamily="49" charset="-122"/>
+                <a:ea typeface="楷体" panose="02010609060101010101" pitchFamily="49" charset="-122"/>
               </a:rPr>
               <a:t>美术老师</a:t>
             </a:r>
             <a:r>
-              <a:rPr lang="zh-CN" altLang="zh-CN" sz="3200" dirty="0"/>
+              <a:rPr lang="zh-CN" altLang="zh-CN" sz="3100" dirty="0">
+                <a:latin typeface="楷体" panose="02010609060101010101" pitchFamily="49" charset="-122"/>
+                <a:ea typeface="楷体" panose="02010609060101010101" pitchFamily="49" charset="-122"/>
+              </a:rPr>
               <a:t>让我们完成了这个</a:t>
             </a:r>
             <a:r>
-              <a:rPr lang="zh-CN" altLang="zh-CN" sz="3200" dirty="0">
+              <a:rPr lang="zh-CN" altLang="zh-CN" sz="3100" dirty="0">
                 <a:highlight>
                   <a:srgbClr val="00FFFF"/>
                 </a:highlight>
+                <a:latin typeface="楷体" panose="02010609060101010101" pitchFamily="49" charset="-122"/>
+                <a:ea typeface="楷体" panose="02010609060101010101" pitchFamily="49" charset="-122"/>
               </a:rPr>
               <a:t>PPT</a:t>
             </a:r>
             <a:r>
-              <a:rPr lang="zh-CN" altLang="zh-CN" sz="3200" dirty="0"/>
+              <a:rPr lang="zh-CN" altLang="zh-CN" sz="3100" dirty="0">
+                <a:latin typeface="楷体" panose="02010609060101010101" pitchFamily="49" charset="-122"/>
+                <a:ea typeface="楷体" panose="02010609060101010101" pitchFamily="49" charset="-122"/>
+              </a:rPr>
               <a:t>。</a:t>
             </a:r>
             <a:br>
-              <a:rPr lang="zh-CN" altLang="zh-CN" sz="3200" dirty="0"/>
+              <a:rPr lang="zh-CN" altLang="zh-CN" sz="3100" dirty="0">
+                <a:latin typeface="楷体" panose="02010609060101010101" pitchFamily="49" charset="-122"/>
+                <a:ea typeface="楷体" panose="02010609060101010101" pitchFamily="49" charset="-122"/>
+              </a:rPr>
             </a:br>
             <a:r>
-              <a:rPr lang="en-US" altLang="zh-CN" sz="3200" dirty="0"/>
+              <a:rPr lang="en-US" altLang="zh-CN" sz="3100" dirty="0">
+                <a:latin typeface="楷体" panose="02010609060101010101" pitchFamily="49" charset="-122"/>
+                <a:ea typeface="楷体" panose="02010609060101010101" pitchFamily="49" charset="-122"/>
+              </a:rPr>
               <a:t>6</a:t>
             </a:r>
             <a:r>
-              <a:rPr lang="zh-CN" altLang="zh-CN" sz="3200" dirty="0"/>
+              <a:rPr lang="zh-CN" altLang="zh-CN" sz="3100" dirty="0">
+                <a:latin typeface="楷体" panose="02010609060101010101" pitchFamily="49" charset="-122"/>
+                <a:ea typeface="楷体" panose="02010609060101010101" pitchFamily="49" charset="-122"/>
+              </a:rPr>
               <a:t>.感谢你</a:t>
             </a:r>
             <a:r>
-              <a:rPr lang="zh-CN" altLang="en-US" sz="3200" dirty="0"/>
+              <a:rPr lang="zh-CN" altLang="en-US" sz="3100" dirty="0">
+                <a:latin typeface="楷体" panose="02010609060101010101" pitchFamily="49" charset="-122"/>
+                <a:ea typeface="楷体" panose="02010609060101010101" pitchFamily="49" charset="-122"/>
+              </a:rPr>
               <a:t>的观看</a:t>
             </a:r>
             <a:r>
-              <a:rPr lang="zh-CN" altLang="zh-CN" sz="3200" dirty="0"/>
+              <a:rPr lang="zh-CN" altLang="zh-CN" sz="3100" dirty="0">
+                <a:latin typeface="楷体" panose="02010609060101010101" pitchFamily="49" charset="-122"/>
+                <a:ea typeface="楷体" panose="02010609060101010101" pitchFamily="49" charset="-122"/>
+              </a:rPr>
               <a:t>——让这个</a:t>
             </a:r>
             <a:r>
-              <a:rPr lang="zh-CN" altLang="zh-CN" sz="3200" dirty="0">
+              <a:rPr lang="zh-CN" altLang="zh-CN" sz="3100" dirty="0">
                 <a:highlight>
                   <a:srgbClr val="00FFFF"/>
                 </a:highlight>
+                <a:latin typeface="楷体" panose="02010609060101010101" pitchFamily="49" charset="-122"/>
+                <a:ea typeface="楷体" panose="02010609060101010101" pitchFamily="49" charset="-122"/>
               </a:rPr>
               <a:t>PPT</a:t>
             </a:r>
             <a:r>
-              <a:rPr lang="zh-CN" altLang="zh-CN" sz="3200" dirty="0"/>
+              <a:rPr lang="zh-CN" altLang="zh-CN" sz="3100" dirty="0">
+                <a:latin typeface="楷体" panose="02010609060101010101" pitchFamily="49" charset="-122"/>
+                <a:ea typeface="楷体" panose="02010609060101010101" pitchFamily="49" charset="-122"/>
+              </a:rPr>
               <a:t>有了存在的意义。</a:t>
             </a:r>
             <a:br>
@@ -9408,10 +9528,10 @@
       </p:pic>
       <p:graphicFrame>
         <p:nvGraphicFramePr>
-          <p:cNvPr id="7" name="表格 6">
+          <p:cNvPr id="3" name="表格 2">
             <a:extLst>
               <a:ext uri="{FF2B5EF4-FFF2-40B4-BE49-F238E27FC236}">
-                <a16:creationId xmlns:a16="http://schemas.microsoft.com/office/drawing/2014/main" id="{03E353EF-1F9C-4AEB-405D-A05F4CB915F0}"/>
+                <a16:creationId xmlns:a16="http://schemas.microsoft.com/office/drawing/2014/main" id="{92FB4A29-44BA-AE6F-B596-77CF1F14AE9B}"/>
               </a:ext>
             </a:extLst>
           </p:cNvPr>
@@ -9421,38 +9541,38 @@
           <p:nvPr>
             <p:extLst>
               <p:ext uri="{D42A27DB-BD31-4B8C-83A1-F6EECF244321}">
-                <p14:modId xmlns:p14="http://schemas.microsoft.com/office/powerpoint/2010/main" val="3858190212"/>
+                <p14:modId xmlns:p14="http://schemas.microsoft.com/office/powerpoint/2010/main" val="2947368288"/>
               </p:ext>
             </p:extLst>
           </p:nvPr>
         </p:nvGraphicFramePr>
         <p:xfrm>
-          <a:off x="6096000" y="366107"/>
-          <a:ext cx="5576347" cy="3418754"/>
+          <a:off x="5712644" y="424206"/>
+          <a:ext cx="5772348" cy="3749751"/>
         </p:xfrm>
         <a:graphic>
           <a:graphicData uri="http://schemas.openxmlformats.org/drawingml/2006/table">
             <a:tbl>
               <a:tblPr>
-                <a:tableStyleId>{5940675A-B579-460E-94D1-54222C63F5DA}</a:tableStyleId>
+                <a:tableStyleId>{5C22544A-7EE6-4342-B048-85BDC9FD1C3A}</a:tableStyleId>
               </a:tblPr>
               <a:tblGrid>
-                <a:gridCol w="1280105">
+                <a:gridCol w="1325099">
                   <a:extLst>
                     <a:ext uri="{9D8B030D-6E8A-4147-A177-3AD203B41FA5}">
-                      <a16:colId xmlns:a16="http://schemas.microsoft.com/office/drawing/2014/main" val="3207987399"/>
+                      <a16:colId xmlns:a16="http://schemas.microsoft.com/office/drawing/2014/main" val="3679975910"/>
                     </a:ext>
                   </a:extLst>
                 </a:gridCol>
-                <a:gridCol w="4296242">
+                <a:gridCol w="4447249">
                   <a:extLst>
                     <a:ext uri="{9D8B030D-6E8A-4147-A177-3AD203B41FA5}">
-                      <a16:colId xmlns:a16="http://schemas.microsoft.com/office/drawing/2014/main" val="2456620992"/>
+                      <a16:colId xmlns:a16="http://schemas.microsoft.com/office/drawing/2014/main" val="1170341243"/>
                     </a:ext>
                   </a:extLst>
                 </a:gridCol>
               </a:tblGrid>
-              <a:tr h="357760">
+              <a:tr h="338486">
                 <a:tc>
                   <a:txBody>
                     <a:bodyPr/>
@@ -9462,18 +9582,20 @@
                         <a:buNone/>
                       </a:pPr>
                       <a:r>
-                        <a:rPr lang="zh-CN" sz="1600" u="none" strike="noStrike">
+                        <a:rPr lang="zh-CN" sz="2400" u="none" strike="noStrike" dirty="0">
                           <a:effectLst/>
+                          <a:latin typeface="楷体" panose="02010609060101010101" pitchFamily="49" charset="-122"/>
+                          <a:ea typeface="楷体" panose="02010609060101010101" pitchFamily="49" charset="-122"/>
                         </a:rPr>
                         <a:t>姓名</a:t>
                       </a:r>
-                      <a:endParaRPr lang="zh-CN" sz="1600" b="0" i="0" u="none" strike="noStrike">
+                      <a:endParaRPr lang="zh-CN" sz="2400" b="0" i="0" u="none" strike="noStrike" dirty="0">
                         <a:solidFill>
                           <a:srgbClr val="000000"/>
                         </a:solidFill>
                         <a:effectLst/>
-                        <a:latin typeface="等线" panose="02010600030101010101" pitchFamily="2" charset="-122"/>
-                        <a:ea typeface="等线" panose="02010600030101010101" pitchFamily="2" charset="-122"/>
+                        <a:latin typeface="楷体" panose="02010609060101010101" pitchFamily="49" charset="-122"/>
+                        <a:ea typeface="楷体" panose="02010609060101010101" pitchFamily="49" charset="-122"/>
                       </a:endParaRPr>
                     </a:p>
                   </a:txBody>
@@ -9488,18 +9610,20 @@
                         <a:buNone/>
                       </a:pPr>
                       <a:r>
-                        <a:rPr lang="zh-CN" sz="1600" u="none" strike="noStrike">
+                        <a:rPr lang="zh-CN" sz="2400" u="none" strike="noStrike" dirty="0">
                           <a:effectLst/>
+                          <a:latin typeface="楷体" panose="02010609060101010101" pitchFamily="49" charset="-122"/>
+                          <a:ea typeface="楷体" panose="02010609060101010101" pitchFamily="49" charset="-122"/>
                         </a:rPr>
                         <a:t>职能</a:t>
                       </a:r>
-                      <a:endParaRPr lang="zh-CN" sz="1600" b="0" i="0" u="none" strike="noStrike">
+                      <a:endParaRPr lang="zh-CN" sz="2400" b="0" i="0" u="none" strike="noStrike" dirty="0">
                         <a:solidFill>
                           <a:srgbClr val="000000"/>
                         </a:solidFill>
                         <a:effectLst/>
-                        <a:latin typeface="等线" panose="02010600030101010101" pitchFamily="2" charset="-122"/>
-                        <a:ea typeface="等线" panose="02010600030101010101" pitchFamily="2" charset="-122"/>
+                        <a:latin typeface="楷体" panose="02010609060101010101" pitchFamily="49" charset="-122"/>
+                        <a:ea typeface="楷体" panose="02010609060101010101" pitchFamily="49" charset="-122"/>
                       </a:endParaRPr>
                     </a:p>
                   </a:txBody>
@@ -9507,11 +9631,11 @@
                 </a:tc>
                 <a:extLst>
                   <a:ext uri="{0D108BD9-81ED-4DB2-BD59-A6C34878D82A}">
-                    <a16:rowId xmlns:a16="http://schemas.microsoft.com/office/drawing/2014/main" val="670625170"/>
+                    <a16:rowId xmlns:a16="http://schemas.microsoft.com/office/drawing/2014/main" val="3415894343"/>
                   </a:ext>
                 </a:extLst>
               </a:tr>
-              <a:tr h="357760">
+              <a:tr h="338486">
                 <a:tc>
                   <a:txBody>
                     <a:bodyPr/>
@@ -9521,18 +9645,20 @@
                         <a:buNone/>
                       </a:pPr>
                       <a:r>
-                        <a:rPr lang="zh-CN" sz="1600" u="none" strike="noStrike">
+                        <a:rPr lang="zh-CN" sz="2400" u="none" strike="noStrike">
                           <a:effectLst/>
+                          <a:latin typeface="楷体" panose="02010609060101010101" pitchFamily="49" charset="-122"/>
+                          <a:ea typeface="楷体" panose="02010609060101010101" pitchFamily="49" charset="-122"/>
                         </a:rPr>
                         <a:t>王语涵</a:t>
                       </a:r>
-                      <a:endParaRPr lang="zh-CN" sz="1600" b="0" i="0" u="none" strike="noStrike">
+                      <a:endParaRPr lang="zh-CN" sz="2400" b="0" i="0" u="none" strike="noStrike">
                         <a:solidFill>
                           <a:srgbClr val="000000"/>
                         </a:solidFill>
                         <a:effectLst/>
-                        <a:latin typeface="等线" panose="02010600030101010101" pitchFamily="2" charset="-122"/>
-                        <a:ea typeface="等线" panose="02010600030101010101" pitchFamily="2" charset="-122"/>
+                        <a:latin typeface="楷体" panose="02010609060101010101" pitchFamily="49" charset="-122"/>
+                        <a:ea typeface="楷体" panose="02010609060101010101" pitchFamily="49" charset="-122"/>
                       </a:endParaRPr>
                     </a:p>
                   </a:txBody>
@@ -9547,18 +9673,20 @@
                         <a:buNone/>
                       </a:pPr>
                       <a:r>
-                        <a:rPr lang="zh-CN" sz="1600" u="none" strike="noStrike">
+                        <a:rPr lang="zh-CN" sz="2400" u="none" strike="noStrike" dirty="0">
                           <a:effectLst/>
+                          <a:latin typeface="楷体" panose="02010609060101010101" pitchFamily="49" charset="-122"/>
+                          <a:ea typeface="楷体" panose="02010609060101010101" pitchFamily="49" charset="-122"/>
                         </a:rPr>
                         <a:t>旁白</a:t>
                       </a:r>
-                      <a:endParaRPr lang="zh-CN" sz="1600" b="0" i="0" u="none" strike="noStrike">
+                      <a:endParaRPr lang="zh-CN" sz="2400" b="0" i="0" u="none" strike="noStrike" dirty="0">
                         <a:solidFill>
                           <a:srgbClr val="000000"/>
                         </a:solidFill>
                         <a:effectLst/>
-                        <a:latin typeface="等线" panose="02010600030101010101" pitchFamily="2" charset="-122"/>
-                        <a:ea typeface="等线" panose="02010600030101010101" pitchFamily="2" charset="-122"/>
+                        <a:latin typeface="楷体" panose="02010609060101010101" pitchFamily="49" charset="-122"/>
+                        <a:ea typeface="楷体" panose="02010609060101010101" pitchFamily="49" charset="-122"/>
                       </a:endParaRPr>
                     </a:p>
                   </a:txBody>
@@ -9566,11 +9694,11 @@
                 </a:tc>
                 <a:extLst>
                   <a:ext uri="{0D108BD9-81ED-4DB2-BD59-A6C34878D82A}">
-                    <a16:rowId xmlns:a16="http://schemas.microsoft.com/office/drawing/2014/main" val="756411464"/>
+                    <a16:rowId xmlns:a16="http://schemas.microsoft.com/office/drawing/2014/main" val="2053225517"/>
                   </a:ext>
                 </a:extLst>
               </a:tr>
-              <a:tr h="357760">
+              <a:tr h="407111">
                 <a:tc>
                   <a:txBody>
                     <a:bodyPr/>
@@ -9580,18 +9708,20 @@
                         <a:buNone/>
                       </a:pPr>
                       <a:r>
-                        <a:rPr lang="zh-CN" sz="1600" u="none" strike="noStrike">
+                        <a:rPr lang="zh-CN" sz="2400" u="none" strike="noStrike">
                           <a:effectLst/>
+                          <a:latin typeface="楷体" panose="02010609060101010101" pitchFamily="49" charset="-122"/>
+                          <a:ea typeface="楷体" panose="02010609060101010101" pitchFamily="49" charset="-122"/>
                         </a:rPr>
                         <a:t>邵炜雅</a:t>
                       </a:r>
-                      <a:endParaRPr lang="zh-CN" sz="1600" b="0" i="0" u="none" strike="noStrike">
+                      <a:endParaRPr lang="zh-CN" sz="2400" b="0" i="0" u="none" strike="noStrike">
                         <a:solidFill>
                           <a:srgbClr val="000000"/>
                         </a:solidFill>
                         <a:effectLst/>
-                        <a:latin typeface="等线" panose="02010600030101010101" pitchFamily="2" charset="-122"/>
-                        <a:ea typeface="等线" panose="02010600030101010101" pitchFamily="2" charset="-122"/>
+                        <a:latin typeface="楷体" panose="02010609060101010101" pitchFamily="49" charset="-122"/>
+                        <a:ea typeface="楷体" panose="02010609060101010101" pitchFamily="49" charset="-122"/>
                       </a:endParaRPr>
                     </a:p>
                   </a:txBody>
@@ -9606,18 +9736,20 @@
                         <a:buNone/>
                       </a:pPr>
                       <a:r>
-                        <a:rPr lang="zh-CN" sz="1600" u="none" strike="noStrike">
+                        <a:rPr lang="zh-CN" sz="2400" u="none" strike="noStrike" dirty="0">
                           <a:effectLst/>
+                          <a:latin typeface="楷体" panose="02010609060101010101" pitchFamily="49" charset="-122"/>
+                          <a:ea typeface="楷体" panose="02010609060101010101" pitchFamily="49" charset="-122"/>
                         </a:rPr>
                         <a:t>旁白</a:t>
                       </a:r>
-                      <a:endParaRPr lang="zh-CN" sz="1600" b="0" i="0" u="none" strike="noStrike">
+                      <a:endParaRPr lang="zh-CN" sz="2400" b="0" i="0" u="none" strike="noStrike" dirty="0">
                         <a:solidFill>
                           <a:srgbClr val="000000"/>
                         </a:solidFill>
                         <a:effectLst/>
-                        <a:latin typeface="等线" panose="02010600030101010101" pitchFamily="2" charset="-122"/>
-                        <a:ea typeface="等线" panose="02010600030101010101" pitchFamily="2" charset="-122"/>
+                        <a:latin typeface="楷体" panose="02010609060101010101" pitchFamily="49" charset="-122"/>
+                        <a:ea typeface="楷体" panose="02010609060101010101" pitchFamily="49" charset="-122"/>
                       </a:endParaRPr>
                     </a:p>
                   </a:txBody>
@@ -9625,11 +9757,11 @@
                 </a:tc>
                 <a:extLst>
                   <a:ext uri="{0D108BD9-81ED-4DB2-BD59-A6C34878D82A}">
-                    <a16:rowId xmlns:a16="http://schemas.microsoft.com/office/drawing/2014/main" val="1806158059"/>
+                    <a16:rowId xmlns:a16="http://schemas.microsoft.com/office/drawing/2014/main" val="1365528667"/>
                   </a:ext>
                 </a:extLst>
               </a:tr>
-              <a:tr h="357760">
+              <a:tr h="338486">
                 <a:tc>
                   <a:txBody>
                     <a:bodyPr/>
@@ -9639,18 +9771,20 @@
                         <a:buNone/>
                       </a:pPr>
                       <a:r>
-                        <a:rPr lang="zh-CN" sz="1600" u="none" strike="noStrike">
+                        <a:rPr lang="zh-CN" sz="2400" u="none" strike="noStrike" dirty="0">
                           <a:effectLst/>
+                          <a:latin typeface="楷体" panose="02010609060101010101" pitchFamily="49" charset="-122"/>
+                          <a:ea typeface="楷体" panose="02010609060101010101" pitchFamily="49" charset="-122"/>
                         </a:rPr>
                         <a:t>赵梓昊</a:t>
                       </a:r>
-                      <a:endParaRPr lang="zh-CN" sz="1600" b="0" i="0" u="none" strike="noStrike">
+                      <a:endParaRPr lang="zh-CN" sz="2400" b="0" i="0" u="none" strike="noStrike" dirty="0">
                         <a:solidFill>
                           <a:srgbClr val="000000"/>
                         </a:solidFill>
                         <a:effectLst/>
-                        <a:latin typeface="等线" panose="02010600030101010101" pitchFamily="2" charset="-122"/>
-                        <a:ea typeface="等线" panose="02010600030101010101" pitchFamily="2" charset="-122"/>
+                        <a:latin typeface="楷体" panose="02010609060101010101" pitchFamily="49" charset="-122"/>
+                        <a:ea typeface="楷体" panose="02010609060101010101" pitchFamily="49" charset="-122"/>
                       </a:endParaRPr>
                     </a:p>
                   </a:txBody>
@@ -9665,18 +9799,20 @@
                         <a:buNone/>
                       </a:pPr>
                       <a:r>
-                        <a:rPr lang="zh-CN" sz="1600" u="none" strike="noStrike">
+                        <a:rPr lang="zh-CN" sz="2400" u="none" strike="noStrike">
                           <a:effectLst/>
+                          <a:latin typeface="楷体" panose="02010609060101010101" pitchFamily="49" charset="-122"/>
+                          <a:ea typeface="楷体" panose="02010609060101010101" pitchFamily="49" charset="-122"/>
                         </a:rPr>
                         <a:t>演员</a:t>
                       </a:r>
-                      <a:endParaRPr lang="zh-CN" sz="1600" b="0" i="0" u="none" strike="noStrike">
+                      <a:endParaRPr lang="zh-CN" sz="2400" b="0" i="0" u="none" strike="noStrike">
                         <a:solidFill>
                           <a:srgbClr val="000000"/>
                         </a:solidFill>
                         <a:effectLst/>
-                        <a:latin typeface="等线" panose="02010600030101010101" pitchFamily="2" charset="-122"/>
-                        <a:ea typeface="等线" panose="02010600030101010101" pitchFamily="2" charset="-122"/>
+                        <a:latin typeface="楷体" panose="02010609060101010101" pitchFamily="49" charset="-122"/>
+                        <a:ea typeface="楷体" panose="02010609060101010101" pitchFamily="49" charset="-122"/>
                       </a:endParaRPr>
                     </a:p>
                   </a:txBody>
@@ -9684,11 +9820,11 @@
                 </a:tc>
                 <a:extLst>
                   <a:ext uri="{0D108BD9-81ED-4DB2-BD59-A6C34878D82A}">
-                    <a16:rowId xmlns:a16="http://schemas.microsoft.com/office/drawing/2014/main" val="1428140260"/>
+                    <a16:rowId xmlns:a16="http://schemas.microsoft.com/office/drawing/2014/main" val="2981144449"/>
                   </a:ext>
                 </a:extLst>
               </a:tr>
-              <a:tr h="357760">
+              <a:tr h="338486">
                 <a:tc>
                   <a:txBody>
                     <a:bodyPr/>
@@ -9698,18 +9834,20 @@
                         <a:buNone/>
                       </a:pPr>
                       <a:r>
-                        <a:rPr lang="zh-CN" sz="1600" u="none" strike="noStrike">
+                        <a:rPr lang="zh-CN" sz="2400" u="none" strike="noStrike">
                           <a:effectLst/>
+                          <a:latin typeface="楷体" panose="02010609060101010101" pitchFamily="49" charset="-122"/>
+                          <a:ea typeface="楷体" panose="02010609060101010101" pitchFamily="49" charset="-122"/>
                         </a:rPr>
                         <a:t>王博然</a:t>
                       </a:r>
-                      <a:endParaRPr lang="zh-CN" sz="1600" b="0" i="0" u="none" strike="noStrike">
+                      <a:endParaRPr lang="zh-CN" sz="2400" b="0" i="0" u="none" strike="noStrike">
                         <a:solidFill>
                           <a:srgbClr val="000000"/>
                         </a:solidFill>
                         <a:effectLst/>
-                        <a:latin typeface="等线" panose="02010600030101010101" pitchFamily="2" charset="-122"/>
-                        <a:ea typeface="等线" panose="02010600030101010101" pitchFamily="2" charset="-122"/>
+                        <a:latin typeface="楷体" panose="02010609060101010101" pitchFamily="49" charset="-122"/>
+                        <a:ea typeface="楷体" panose="02010609060101010101" pitchFamily="49" charset="-122"/>
                       </a:endParaRPr>
                     </a:p>
                   </a:txBody>
@@ -9724,18 +9862,20 @@
                         <a:buNone/>
                       </a:pPr>
                       <a:r>
-                        <a:rPr lang="zh-CN" sz="1600" u="none" strike="noStrike">
+                        <a:rPr lang="zh-CN" sz="2400" u="none" strike="noStrike" dirty="0">
                           <a:effectLst/>
+                          <a:latin typeface="楷体" panose="02010609060101010101" pitchFamily="49" charset="-122"/>
+                          <a:ea typeface="楷体" panose="02010609060101010101" pitchFamily="49" charset="-122"/>
                         </a:rPr>
                         <a:t>演员</a:t>
                       </a:r>
-                      <a:endParaRPr lang="zh-CN" sz="1600" b="0" i="0" u="none" strike="noStrike">
+                      <a:endParaRPr lang="zh-CN" sz="2400" b="0" i="0" u="none" strike="noStrike" dirty="0">
                         <a:solidFill>
                           <a:srgbClr val="000000"/>
                         </a:solidFill>
                         <a:effectLst/>
-                        <a:latin typeface="等线" panose="02010600030101010101" pitchFamily="2" charset="-122"/>
-                        <a:ea typeface="等线" panose="02010600030101010101" pitchFamily="2" charset="-122"/>
+                        <a:latin typeface="楷体" panose="02010609060101010101" pitchFamily="49" charset="-122"/>
+                        <a:ea typeface="楷体" panose="02010609060101010101" pitchFamily="49" charset="-122"/>
                       </a:endParaRPr>
                     </a:p>
                   </a:txBody>
@@ -9743,11 +9883,11 @@
                 </a:tc>
                 <a:extLst>
                   <a:ext uri="{0D108BD9-81ED-4DB2-BD59-A6C34878D82A}">
-                    <a16:rowId xmlns:a16="http://schemas.microsoft.com/office/drawing/2014/main" val="1590098318"/>
+                    <a16:rowId xmlns:a16="http://schemas.microsoft.com/office/drawing/2014/main" val="1790334079"/>
                   </a:ext>
                 </a:extLst>
               </a:tr>
-              <a:tr h="357760">
+              <a:tr h="338486">
                 <a:tc>
                   <a:txBody>
                     <a:bodyPr/>
@@ -9757,18 +9897,20 @@
                         <a:buNone/>
                       </a:pPr>
                       <a:r>
-                        <a:rPr lang="zh-CN" sz="1600" u="none" strike="noStrike">
+                        <a:rPr lang="zh-CN" sz="2400" u="none" strike="noStrike">
                           <a:effectLst/>
+                          <a:latin typeface="楷体" panose="02010609060101010101" pitchFamily="49" charset="-122"/>
+                          <a:ea typeface="楷体" panose="02010609060101010101" pitchFamily="49" charset="-122"/>
                         </a:rPr>
                         <a:t>张贺衍</a:t>
                       </a:r>
-                      <a:endParaRPr lang="zh-CN" sz="1600" b="0" i="0" u="none" strike="noStrike">
+                      <a:endParaRPr lang="zh-CN" sz="2400" b="0" i="0" u="none" strike="noStrike">
                         <a:solidFill>
                           <a:srgbClr val="000000"/>
                         </a:solidFill>
                         <a:effectLst/>
-                        <a:latin typeface="等线" panose="02010600030101010101" pitchFamily="2" charset="-122"/>
-                        <a:ea typeface="等线" panose="02010600030101010101" pitchFamily="2" charset="-122"/>
+                        <a:latin typeface="楷体" panose="02010609060101010101" pitchFamily="49" charset="-122"/>
+                        <a:ea typeface="楷体" panose="02010609060101010101" pitchFamily="49" charset="-122"/>
                       </a:endParaRPr>
                     </a:p>
                   </a:txBody>
@@ -9783,18 +9925,20 @@
                         <a:buNone/>
                       </a:pPr>
                       <a:r>
-                        <a:rPr lang="zh-CN" sz="1600" u="none" strike="noStrike">
+                        <a:rPr lang="zh-CN" sz="2400" u="none" strike="noStrike" dirty="0">
                           <a:effectLst/>
+                          <a:latin typeface="楷体" panose="02010609060101010101" pitchFamily="49" charset="-122"/>
+                          <a:ea typeface="楷体" panose="02010609060101010101" pitchFamily="49" charset="-122"/>
                         </a:rPr>
                         <a:t>ppt制作（3，4，5 页），演员</a:t>
                       </a:r>
-                      <a:endParaRPr lang="zh-CN" sz="1600" b="0" i="0" u="none" strike="noStrike">
+                      <a:endParaRPr lang="zh-CN" sz="2400" b="0" i="0" u="none" strike="noStrike" dirty="0">
                         <a:solidFill>
                           <a:srgbClr val="000000"/>
                         </a:solidFill>
                         <a:effectLst/>
-                        <a:latin typeface="等线" panose="02010600030101010101" pitchFamily="2" charset="-122"/>
-                        <a:ea typeface="等线" panose="02010600030101010101" pitchFamily="2" charset="-122"/>
+                        <a:latin typeface="楷体" panose="02010609060101010101" pitchFamily="49" charset="-122"/>
+                        <a:ea typeface="楷体" panose="02010609060101010101" pitchFamily="49" charset="-122"/>
                       </a:endParaRPr>
                     </a:p>
                   </a:txBody>
@@ -9802,11 +9946,11 @@
                 </a:tc>
                 <a:extLst>
                   <a:ext uri="{0D108BD9-81ED-4DB2-BD59-A6C34878D82A}">
-                    <a16:rowId xmlns:a16="http://schemas.microsoft.com/office/drawing/2014/main" val="1054622054"/>
+                    <a16:rowId xmlns:a16="http://schemas.microsoft.com/office/drawing/2014/main" val="3068033332"/>
                   </a:ext>
                 </a:extLst>
               </a:tr>
-              <a:tr h="357760">
+              <a:tr h="338486">
                 <a:tc>
                   <a:txBody>
                     <a:bodyPr/>
@@ -9816,18 +9960,20 @@
                         <a:buNone/>
                       </a:pPr>
                       <a:r>
-                        <a:rPr lang="zh-CN" sz="1600" u="none" strike="noStrike">
+                        <a:rPr lang="zh-CN" sz="2400" u="none" strike="noStrike">
                           <a:effectLst/>
+                          <a:latin typeface="楷体" panose="02010609060101010101" pitchFamily="49" charset="-122"/>
+                          <a:ea typeface="楷体" panose="02010609060101010101" pitchFamily="49" charset="-122"/>
                         </a:rPr>
                         <a:t>郭柄君</a:t>
                       </a:r>
-                      <a:endParaRPr lang="zh-CN" sz="1600" b="0" i="0" u="none" strike="noStrike">
+                      <a:endParaRPr lang="zh-CN" sz="2400" b="0" i="0" u="none" strike="noStrike">
                         <a:solidFill>
                           <a:srgbClr val="000000"/>
                         </a:solidFill>
                         <a:effectLst/>
-                        <a:latin typeface="等线" panose="02010600030101010101" pitchFamily="2" charset="-122"/>
-                        <a:ea typeface="等线" panose="02010600030101010101" pitchFamily="2" charset="-122"/>
+                        <a:latin typeface="楷体" panose="02010609060101010101" pitchFamily="49" charset="-122"/>
+                        <a:ea typeface="楷体" panose="02010609060101010101" pitchFamily="49" charset="-122"/>
                       </a:endParaRPr>
                     </a:p>
                   </a:txBody>
@@ -9842,18 +9988,20 @@
                         <a:buNone/>
                       </a:pPr>
                       <a:r>
-                        <a:rPr lang="zh-CN" sz="1600" u="none" strike="noStrike">
+                        <a:rPr lang="zh-CN" sz="2400" u="none" strike="noStrike" dirty="0">
                           <a:effectLst/>
+                          <a:latin typeface="楷体" panose="02010609060101010101" pitchFamily="49" charset="-122"/>
+                          <a:ea typeface="楷体" panose="02010609060101010101" pitchFamily="49" charset="-122"/>
                         </a:rPr>
                         <a:t>演员</a:t>
                       </a:r>
-                      <a:endParaRPr lang="zh-CN" sz="1600" b="0" i="0" u="none" strike="noStrike">
+                      <a:endParaRPr lang="zh-CN" sz="2400" b="0" i="0" u="none" strike="noStrike" dirty="0">
                         <a:solidFill>
                           <a:srgbClr val="000000"/>
                         </a:solidFill>
                         <a:effectLst/>
-                        <a:latin typeface="等线" panose="02010600030101010101" pitchFamily="2" charset="-122"/>
-                        <a:ea typeface="等线" panose="02010600030101010101" pitchFamily="2" charset="-122"/>
+                        <a:latin typeface="楷体" panose="02010609060101010101" pitchFamily="49" charset="-122"/>
+                        <a:ea typeface="楷体" panose="02010609060101010101" pitchFamily="49" charset="-122"/>
                       </a:endParaRPr>
                     </a:p>
                   </a:txBody>
@@ -9861,11 +10009,11 @@
                 </a:tc>
                 <a:extLst>
                   <a:ext uri="{0D108BD9-81ED-4DB2-BD59-A6C34878D82A}">
-                    <a16:rowId xmlns:a16="http://schemas.microsoft.com/office/drawing/2014/main" val="2961987211"/>
+                    <a16:rowId xmlns:a16="http://schemas.microsoft.com/office/drawing/2014/main" val="2846394497"/>
                   </a:ext>
                 </a:extLst>
               </a:tr>
-              <a:tr h="556674">
+              <a:tr h="526684">
                 <a:tc>
                   <a:txBody>
                     <a:bodyPr/>
@@ -9875,18 +10023,20 @@
                         <a:buNone/>
                       </a:pPr>
                       <a:r>
-                        <a:rPr lang="zh-CN" sz="1600" u="none" strike="noStrike">
+                        <a:rPr lang="zh-CN" sz="2400" u="none" strike="noStrike">
                           <a:effectLst/>
+                          <a:latin typeface="楷体" panose="02010609060101010101" pitchFamily="49" charset="-122"/>
+                          <a:ea typeface="楷体" panose="02010609060101010101" pitchFamily="49" charset="-122"/>
                         </a:rPr>
                         <a:t>刘安泽</a:t>
                       </a:r>
-                      <a:endParaRPr lang="zh-CN" sz="1600" b="0" i="0" u="none" strike="noStrike">
+                      <a:endParaRPr lang="zh-CN" sz="2400" b="0" i="0" u="none" strike="noStrike">
                         <a:solidFill>
                           <a:srgbClr val="000000"/>
                         </a:solidFill>
                         <a:effectLst/>
-                        <a:latin typeface="等线" panose="02010600030101010101" pitchFamily="2" charset="-122"/>
-                        <a:ea typeface="等线" panose="02010600030101010101" pitchFamily="2" charset="-122"/>
+                        <a:latin typeface="楷体" panose="02010609060101010101" pitchFamily="49" charset="-122"/>
+                        <a:ea typeface="楷体" panose="02010609060101010101" pitchFamily="49" charset="-122"/>
                       </a:endParaRPr>
                     </a:p>
                   </a:txBody>
@@ -9901,18 +10051,20 @@
                         <a:buNone/>
                       </a:pPr>
                       <a:r>
-                        <a:rPr lang="zh-CN" sz="1600" u="none" strike="noStrike">
+                        <a:rPr lang="zh-CN" sz="2400" u="none" strike="noStrike" dirty="0">
                           <a:effectLst/>
+                          <a:latin typeface="楷体" panose="02010609060101010101" pitchFamily="49" charset="-122"/>
+                          <a:ea typeface="楷体" panose="02010609060101010101" pitchFamily="49" charset="-122"/>
                         </a:rPr>
                         <a:t>ppt制作（1，2，6 页），ppt播放</a:t>
                       </a:r>
-                      <a:endParaRPr lang="zh-CN" sz="1600" b="0" i="0" u="none" strike="noStrike">
+                      <a:endParaRPr lang="zh-CN" sz="2400" b="0" i="0" u="none" strike="noStrike" dirty="0">
                         <a:solidFill>
                           <a:srgbClr val="000000"/>
                         </a:solidFill>
                         <a:effectLst/>
-                        <a:latin typeface="等线" panose="02010600030101010101" pitchFamily="2" charset="-122"/>
-                        <a:ea typeface="等线" panose="02010600030101010101" pitchFamily="2" charset="-122"/>
+                        <a:latin typeface="楷体" panose="02010609060101010101" pitchFamily="49" charset="-122"/>
+                        <a:ea typeface="楷体" panose="02010609060101010101" pitchFamily="49" charset="-122"/>
                       </a:endParaRPr>
                     </a:p>
                   </a:txBody>
@@ -9920,11 +10072,11 @@
                 </a:tc>
                 <a:extLst>
                   <a:ext uri="{0D108BD9-81ED-4DB2-BD59-A6C34878D82A}">
-                    <a16:rowId xmlns:a16="http://schemas.microsoft.com/office/drawing/2014/main" val="3588945687"/>
+                    <a16:rowId xmlns:a16="http://schemas.microsoft.com/office/drawing/2014/main" val="19802490"/>
                   </a:ext>
                 </a:extLst>
               </a:tr>
-              <a:tr h="357760">
+              <a:tr h="338486">
                 <a:tc>
                   <a:txBody>
                     <a:bodyPr/>
@@ -9934,18 +10086,20 @@
                         <a:buNone/>
                       </a:pPr>
                       <a:r>
-                        <a:rPr lang="zh-CN" sz="1600" u="none" strike="noStrike">
+                        <a:rPr lang="zh-CN" sz="2400" u="none" strike="noStrike">
                           <a:effectLst/>
+                          <a:latin typeface="楷体" panose="02010609060101010101" pitchFamily="49" charset="-122"/>
+                          <a:ea typeface="楷体" panose="02010609060101010101" pitchFamily="49" charset="-122"/>
                         </a:rPr>
                         <a:t>姜昱言</a:t>
                       </a:r>
-                      <a:endParaRPr lang="zh-CN" sz="1600" b="0" i="0" u="none" strike="noStrike">
+                      <a:endParaRPr lang="zh-CN" sz="2400" b="0" i="0" u="none" strike="noStrike">
                         <a:solidFill>
                           <a:srgbClr val="000000"/>
                         </a:solidFill>
                         <a:effectLst/>
-                        <a:latin typeface="等线" panose="02010600030101010101" pitchFamily="2" charset="-122"/>
-                        <a:ea typeface="等线" panose="02010600030101010101" pitchFamily="2" charset="-122"/>
+                        <a:latin typeface="楷体" panose="02010609060101010101" pitchFamily="49" charset="-122"/>
+                        <a:ea typeface="楷体" panose="02010609060101010101" pitchFamily="49" charset="-122"/>
                       </a:endParaRPr>
                     </a:p>
                   </a:txBody>
@@ -9960,18 +10114,20 @@
                         <a:buNone/>
                       </a:pPr>
                       <a:r>
-                        <a:rPr lang="zh-CN" sz="1600" u="none" strike="noStrike" dirty="0">
+                        <a:rPr lang="zh-CN" sz="2400" u="none" strike="noStrike" dirty="0">
                           <a:effectLst/>
+                          <a:latin typeface="楷体" panose="02010609060101010101" pitchFamily="49" charset="-122"/>
+                          <a:ea typeface="楷体" panose="02010609060101010101" pitchFamily="49" charset="-122"/>
                         </a:rPr>
                         <a:t>文稿书写</a:t>
                       </a:r>
-                      <a:endParaRPr lang="zh-CN" sz="1600" b="0" i="0" u="none" strike="noStrike" dirty="0">
+                      <a:endParaRPr lang="zh-CN" sz="2400" b="0" i="0" u="none" strike="noStrike" dirty="0">
                         <a:solidFill>
                           <a:srgbClr val="000000"/>
                         </a:solidFill>
                         <a:effectLst/>
-                        <a:latin typeface="等线" panose="02010600030101010101" pitchFamily="2" charset="-122"/>
-                        <a:ea typeface="等线" panose="02010600030101010101" pitchFamily="2" charset="-122"/>
+                        <a:latin typeface="楷体" panose="02010609060101010101" pitchFamily="49" charset="-122"/>
+                        <a:ea typeface="楷体" panose="02010609060101010101" pitchFamily="49" charset="-122"/>
                       </a:endParaRPr>
                     </a:p>
                   </a:txBody>
@@ -9979,7 +10135,7 @@
                 </a:tc>
                 <a:extLst>
                   <a:ext uri="{0D108BD9-81ED-4DB2-BD59-A6C34878D82A}">
-                    <a16:rowId xmlns:a16="http://schemas.microsoft.com/office/drawing/2014/main" val="524005334"/>
+                    <a16:rowId xmlns:a16="http://schemas.microsoft.com/office/drawing/2014/main" val="2419240313"/>
                   </a:ext>
                 </a:extLst>
               </a:tr>

</xml_diff>

<commit_message>
modified:   README.md 	modified:   "\343\200\212\345\215\203\345\271\264\345\234\237\345\234\260\347\277\273\344\272\206\350\272\253\343\200\213.pptx"
</commit_message>
<xml_diff>
--- a/《千年土地翻了身》.pptx
+++ b/《千年土地翻了身》.pptx
@@ -9541,7 +9541,7 @@
           <p:nvPr>
             <p:extLst>
               <p:ext uri="{D42A27DB-BD31-4B8C-83A1-F6EECF244321}">
-                <p14:modId xmlns:p14="http://schemas.microsoft.com/office/powerpoint/2010/main" val="2947368288"/>
+                <p14:modId xmlns:p14="http://schemas.microsoft.com/office/powerpoint/2010/main" val="2402033706"/>
               </p:ext>
             </p:extLst>
           </p:nvPr>
@@ -10114,12 +10114,28 @@
                         <a:buNone/>
                       </a:pPr>
                       <a:r>
+                        <a:rPr lang="zh-CN" altLang="en-US" sz="2400" u="none" strike="noStrike">
+                          <a:effectLst/>
+                          <a:latin typeface="楷体" panose="02010609060101010101" pitchFamily="49" charset="-122"/>
+                          <a:ea typeface="楷体" panose="02010609060101010101" pitchFamily="49" charset="-122"/>
+                        </a:rPr>
+                        <a:t>剧本、旁白</a:t>
+                      </a:r>
+                      <a:r>
+                        <a:rPr lang="zh-CN" sz="2400" u="none" strike="noStrike">
+                          <a:effectLst/>
+                          <a:latin typeface="楷体" panose="02010609060101010101" pitchFamily="49" charset="-122"/>
+                          <a:ea typeface="楷体" panose="02010609060101010101" pitchFamily="49" charset="-122"/>
+                        </a:rPr>
+                        <a:t>书</a:t>
+                      </a:r>
+                      <a:r>
                         <a:rPr lang="zh-CN" sz="2400" u="none" strike="noStrike" dirty="0">
                           <a:effectLst/>
                           <a:latin typeface="楷体" panose="02010609060101010101" pitchFamily="49" charset="-122"/>
                           <a:ea typeface="楷体" panose="02010609060101010101" pitchFamily="49" charset="-122"/>
                         </a:rPr>
-                        <a:t>文稿书写</a:t>
+                        <a:t>写</a:t>
                       </a:r>
                       <a:endParaRPr lang="zh-CN" sz="2400" b="0" i="0" u="none" strike="noStrike" dirty="0">
                         <a:solidFill>

</xml_diff>